<commit_message>
Minor change - TBC
</commit_message>
<xml_diff>
--- a/pptx/05 Python-for-DSML.pptx
+++ b/pptx/05 Python-for-DSML.pptx
@@ -239,7 +239,7 @@
           <a:p>
             <a:fld id="{A1BC9B43-6C86-4105-AE8A-26C6AC82A911}" type="datetimeFigureOut">
               <a:rPr lang="en-US" smtClean="0"/>
-              <a:t>8/21/2025</a:t>
+              <a:t>10/13/2025</a:t>
             </a:fld>
             <a:endParaRPr lang="en-US"/>
           </a:p>
@@ -910,7 +910,7 @@
           <a:p>
             <a:fld id="{350E461F-61FE-4D81-8611-0097AAEF7B68}" type="datetime1">
               <a:rPr lang="en-US" smtClean="0"/>
-              <a:t>8/21/2025</a:t>
+              <a:t>10/13/2025</a:t>
             </a:fld>
             <a:endParaRPr lang="en-US"/>
           </a:p>
@@ -1078,7 +1078,7 @@
           <a:p>
             <a:fld id="{EC93E650-B1F9-41B7-A814-30DF5D824348}" type="datetime1">
               <a:rPr lang="en-US" smtClean="0"/>
-              <a:t>8/21/2025</a:t>
+              <a:t>10/13/2025</a:t>
             </a:fld>
             <a:endParaRPr lang="en-US"/>
           </a:p>
@@ -1256,7 +1256,7 @@
           <a:p>
             <a:fld id="{73C66AA3-ECFC-423D-9D1F-F2B307D4D685}" type="datetime1">
               <a:rPr lang="en-US" smtClean="0"/>
-              <a:t>8/21/2025</a:t>
+              <a:t>10/13/2025</a:t>
             </a:fld>
             <a:endParaRPr lang="en-US"/>
           </a:p>
@@ -1725,7 +1725,7 @@
           <a:p>
             <a:fld id="{74946075-E8DF-4742-8C24-79E95A67D237}" type="datetime1">
               <a:rPr lang="en-US" smtClean="0"/>
-              <a:t>8/21/2025</a:t>
+              <a:t>10/13/2025</a:t>
             </a:fld>
             <a:endParaRPr lang="en-US"/>
           </a:p>
@@ -1970,7 +1970,7 @@
           <a:p>
             <a:fld id="{7B0B2289-7CF1-4619-A455-B0B4017B374E}" type="datetime1">
               <a:rPr lang="en-US" smtClean="0"/>
-              <a:t>8/21/2025</a:t>
+              <a:t>10/13/2025</a:t>
             </a:fld>
             <a:endParaRPr lang="en-US"/>
           </a:p>
@@ -2199,7 +2199,7 @@
           <a:p>
             <a:fld id="{E94FDEA8-FDD0-47AB-9B1E-6412E7EC60D7}" type="datetime1">
               <a:rPr lang="en-US" smtClean="0"/>
-              <a:t>8/21/2025</a:t>
+              <a:t>10/13/2025</a:t>
             </a:fld>
             <a:endParaRPr lang="en-US"/>
           </a:p>
@@ -2563,7 +2563,7 @@
           <a:p>
             <a:fld id="{7957D6ED-9C9A-4467-8EC7-039C0829B3DE}" type="datetime1">
               <a:rPr lang="en-US" smtClean="0"/>
-              <a:t>8/21/2025</a:t>
+              <a:t>10/13/2025</a:t>
             </a:fld>
             <a:endParaRPr lang="en-US"/>
           </a:p>
@@ -2680,7 +2680,7 @@
           <a:p>
             <a:fld id="{5D9C30DE-6A64-4BEE-8EF3-DF084BEA05C1}" type="datetime1">
               <a:rPr lang="en-US" smtClean="0"/>
-              <a:t>8/21/2025</a:t>
+              <a:t>10/13/2025</a:t>
             </a:fld>
             <a:endParaRPr lang="en-US"/>
           </a:p>
@@ -2775,7 +2775,7 @@
           <a:p>
             <a:fld id="{8CB4CAAF-2F01-498F-89B0-DB7EA8EC2343}" type="datetime1">
               <a:rPr lang="en-US" smtClean="0"/>
-              <a:t>8/21/2025</a:t>
+              <a:t>10/13/2025</a:t>
             </a:fld>
             <a:endParaRPr lang="en-US"/>
           </a:p>
@@ -3050,7 +3050,7 @@
           <a:p>
             <a:fld id="{4F10F7E6-27E1-42EF-8BDB-5661503F4C2D}" type="datetime1">
               <a:rPr lang="en-US" smtClean="0"/>
-              <a:t>8/21/2025</a:t>
+              <a:t>10/13/2025</a:t>
             </a:fld>
             <a:endParaRPr lang="en-US"/>
           </a:p>
@@ -3302,7 +3302,7 @@
           <a:p>
             <a:fld id="{04F16676-04F5-493E-A02A-6B73A4AE7951}" type="datetime1">
               <a:rPr lang="en-US" smtClean="0"/>
-              <a:t>8/21/2025</a:t>
+              <a:t>10/13/2025</a:t>
             </a:fld>
             <a:endParaRPr lang="en-US"/>
           </a:p>
@@ -3513,7 +3513,7 @@
           <a:p>
             <a:fld id="{A0969F45-234F-4D98-8AAE-7ED1F80960E9}" type="datetime1">
               <a:rPr lang="en-US" smtClean="0"/>
-              <a:t>8/21/2025</a:t>
+              <a:t>10/13/2025</a:t>
             </a:fld>
             <a:endParaRPr lang="en-US"/>
           </a:p>
@@ -9739,7 +9739,7 @@
           <a:p>
             <a:pPr algn="ctr"/>
             <a:r>
-              <a:rPr lang="en" sz="1467" dirty="0">
+              <a:rPr lang="en" sz="1467" strike="sngStrike" dirty="0">
                 <a:solidFill>
                   <a:schemeClr val="accent1"/>
                 </a:solidFill>
@@ -9748,7 +9748,7 @@
               <a:t>4</a:t>
             </a:r>
             <a:r>
-              <a:rPr lang="en" sz="1600" dirty="0">
+              <a:rPr lang="en" sz="1600" strike="sngStrike" dirty="0">
                 <a:solidFill>
                   <a:schemeClr val="accent1"/>
                 </a:solidFill>
@@ -9756,7 +9756,7 @@
               </a:rPr>
               <a:t>.* - Natural Language Processing (NLP)</a:t>
             </a:r>
-            <a:endParaRPr sz="1600" dirty="0">
+            <a:endParaRPr sz="1600" strike="sngStrike" dirty="0">
               <a:solidFill>
                 <a:schemeClr val="accent1"/>
               </a:solidFill>
@@ -9880,7 +9880,7 @@
           <a:p>
             <a:pPr algn="ctr"/>
             <a:r>
-              <a:rPr lang="en" sz="1467" dirty="0">
+              <a:rPr lang="en" sz="1467" strike="sngStrike" dirty="0">
                 <a:solidFill>
                   <a:schemeClr val="accent1"/>
                 </a:solidFill>
@@ -9888,7 +9888,7 @@
               </a:rPr>
               <a:t>2.5 - KNN</a:t>
             </a:r>
-            <a:endParaRPr sz="1467" dirty="0">
+            <a:endParaRPr sz="1467" strike="sngStrike" dirty="0">
               <a:solidFill>
                 <a:schemeClr val="accent1"/>
               </a:solidFill>
@@ -9932,7 +9932,7 @@
           <a:p>
             <a:pPr algn="ctr"/>
             <a:r>
-              <a:rPr lang="en" sz="1600" dirty="0">
+              <a:rPr lang="en" sz="1600" strike="sngStrike" dirty="0">
                 <a:solidFill>
                   <a:schemeClr val="accent1"/>
                 </a:solidFill>
@@ -9940,7 +9940,7 @@
               </a:rPr>
               <a:t>3.2 - Neural Networks</a:t>
             </a:r>
-            <a:endParaRPr sz="1600" dirty="0">
+            <a:endParaRPr sz="1600" strike="sngStrike" dirty="0">
               <a:solidFill>
                 <a:schemeClr val="accent1"/>
               </a:solidFill>

</xml_diff>

<commit_message>
Extend the slides + corresponding csv file
</commit_message>
<xml_diff>
--- a/pptx/05 Python-for-DSML.pptx
+++ b/pptx/05 Python-for-DSML.pptx
@@ -5,7 +5,7 @@
     <p:sldMasterId id="2147483648" r:id="rId1"/>
   </p:sldMasterIdLst>
   <p:notesMasterIdLst>
-    <p:notesMasterId r:id="rId45"/>
+    <p:notesMasterId r:id="rId46"/>
   </p:notesMasterIdLst>
   <p:sldIdLst>
     <p:sldId id="256" r:id="rId2"/>
@@ -43,14 +43,15 @@
     <p:sldId id="290" r:id="rId34"/>
     <p:sldId id="291" r:id="rId35"/>
     <p:sldId id="292" r:id="rId36"/>
-    <p:sldId id="293" r:id="rId37"/>
-    <p:sldId id="294" r:id="rId38"/>
-    <p:sldId id="295" r:id="rId39"/>
-    <p:sldId id="297" r:id="rId40"/>
-    <p:sldId id="296" r:id="rId41"/>
-    <p:sldId id="298" r:id="rId42"/>
-    <p:sldId id="299" r:id="rId43"/>
-    <p:sldId id="302" r:id="rId44"/>
+    <p:sldId id="304" r:id="rId37"/>
+    <p:sldId id="293" r:id="rId38"/>
+    <p:sldId id="294" r:id="rId39"/>
+    <p:sldId id="295" r:id="rId40"/>
+    <p:sldId id="297" r:id="rId41"/>
+    <p:sldId id="296" r:id="rId42"/>
+    <p:sldId id="298" r:id="rId43"/>
+    <p:sldId id="299" r:id="rId44"/>
+    <p:sldId id="302" r:id="rId45"/>
   </p:sldIdLst>
   <p:sldSz cx="12192000" cy="6858000"/>
   <p:notesSz cx="6858000" cy="9144000"/>
@@ -239,7 +240,7 @@
           <a:p>
             <a:fld id="{A1BC9B43-6C86-4105-AE8A-26C6AC82A911}" type="datetimeFigureOut">
               <a:rPr lang="en-US" smtClean="0"/>
-              <a:t>11/5/2025</a:t>
+              <a:t>11/12/2025</a:t>
             </a:fld>
             <a:endParaRPr lang="en-US"/>
           </a:p>
@@ -397,7 +398,7 @@
           <a:p>
             <a:fld id="{1C35B555-7100-4285-9AD5-4C99DEA7ECE6}" type="slidenum">
               <a:rPr lang="en-US" smtClean="0"/>
-              <a:t>‹#›</a:t>
+              <a:t>‹Nr.›</a:t>
             </a:fld>
             <a:endParaRPr lang="en-US"/>
           </a:p>
@@ -781,6 +782,656 @@
 </p:notes>
 </file>
 
+<file path=ppt/notesSlides/notesSlide4.xml><?xml version="1.0" encoding="utf-8"?>
+<p:notes xmlns:a="http://schemas.openxmlformats.org/drawingml/2006/main" xmlns:r="http://schemas.openxmlformats.org/officeDocument/2006/relationships" xmlns:p="http://schemas.openxmlformats.org/presentationml/2006/main">
+  <p:cSld>
+    <p:spTree>
+      <p:nvGrpSpPr>
+        <p:cNvPr id="1" name=""/>
+        <p:cNvGrpSpPr/>
+        <p:nvPr/>
+      </p:nvGrpSpPr>
+      <p:grpSpPr>
+        <a:xfrm>
+          <a:off x="0" y="0"/>
+          <a:ext cx="0" cy="0"/>
+          <a:chOff x="0" y="0"/>
+          <a:chExt cx="0" cy="0"/>
+        </a:xfrm>
+      </p:grpSpPr>
+      <p:sp>
+        <p:nvSpPr>
+          <p:cNvPr id="2" name="Folienbildplatzhalter 1"/>
+          <p:cNvSpPr>
+            <a:spLocks noGrp="1" noRot="1" noChangeAspect="1"/>
+          </p:cNvSpPr>
+          <p:nvPr>
+            <p:ph type="sldImg"/>
+          </p:nvPr>
+        </p:nvSpPr>
+        <p:spPr/>
+      </p:sp>
+      <p:sp>
+        <p:nvSpPr>
+          <p:cNvPr id="3" name="Notizenplatzhalter 2"/>
+          <p:cNvSpPr>
+            <a:spLocks noGrp="1"/>
+          </p:cNvSpPr>
+          <p:nvPr>
+            <p:ph type="body" idx="1"/>
+          </p:nvPr>
+        </p:nvSpPr>
+        <p:spPr/>
+        <p:txBody>
+          <a:bodyPr/>
+          <a:lstStyle/>
+          <a:p>
+            <a:r>
+              <a:rPr lang="en-US" sz="1200" b="0" i="0" kern="1200" dirty="0">
+                <a:solidFill>
+                  <a:schemeClr val="tx1"/>
+                </a:solidFill>
+                <a:effectLst/>
+                <a:latin typeface="+mn-lt"/>
+                <a:ea typeface="+mn-ea"/>
+                <a:cs typeface="+mn-cs"/>
+              </a:rPr>
+              <a:t>Rows with at least one missing value: </a:t>
+            </a:r>
+            <a:r>
+              <a:rPr lang="en-US" sz="1200" b="1" i="0" kern="1200" dirty="0">
+                <a:solidFill>
+                  <a:schemeClr val="tx1"/>
+                </a:solidFill>
+                <a:effectLst/>
+                <a:latin typeface="+mn-lt"/>
+                <a:ea typeface="+mn-ea"/>
+                <a:cs typeface="+mn-cs"/>
+              </a:rPr>
+              <a:t>flights[</a:t>
+            </a:r>
+            <a:r>
+              <a:rPr lang="en-US" sz="1200" b="1" i="0" kern="1200" dirty="0" err="1">
+                <a:solidFill>
+                  <a:schemeClr val="tx1"/>
+                </a:solidFill>
+                <a:effectLst/>
+                <a:latin typeface="+mn-lt"/>
+                <a:ea typeface="+mn-ea"/>
+                <a:cs typeface="+mn-cs"/>
+              </a:rPr>
+              <a:t>flights.isnull</a:t>
+            </a:r>
+            <a:r>
+              <a:rPr lang="en-US" sz="1200" b="1" i="0" kern="1200" dirty="0">
+                <a:solidFill>
+                  <a:schemeClr val="tx1"/>
+                </a:solidFill>
+                <a:effectLst/>
+                <a:latin typeface="+mn-lt"/>
+                <a:ea typeface="+mn-ea"/>
+                <a:cs typeface="+mn-cs"/>
+              </a:rPr>
+              <a:t>().any(axis=1)]</a:t>
+            </a:r>
+          </a:p>
+          <a:p>
+            <a:pPr marL="171450" marR="0" lvl="0" indent="-171450" algn="l" defTabSz="914400" rtl="0" eaLnBrk="1" fontAlgn="auto" latinLnBrk="0" hangingPunct="1">
+              <a:lnSpc>
+                <a:spcPct val="100000"/>
+              </a:lnSpc>
+              <a:spcBef>
+                <a:spcPts val="0"/>
+              </a:spcBef>
+              <a:spcAft>
+                <a:spcPts val="0"/>
+              </a:spcAft>
+              <a:buClrTx/>
+              <a:buSzTx/>
+              <a:buFont typeface="Arial" panose="020B0604020202020204" pitchFamily="34" charset="0"/>
+              <a:buChar char="•"/>
+              <a:tabLst/>
+              <a:defRPr/>
+            </a:pPr>
+            <a:r>
+              <a:rPr lang="en-US" sz="1200" b="0" i="0" kern="1200" dirty="0">
+                <a:solidFill>
+                  <a:schemeClr val="tx1"/>
+                </a:solidFill>
+                <a:effectLst/>
+                <a:latin typeface="+mn-lt"/>
+                <a:ea typeface="+mn-ea"/>
+                <a:cs typeface="+mn-cs"/>
+              </a:rPr>
+              <a:t>Use axis=1 to filter rows based on missing data.</a:t>
+            </a:r>
+          </a:p>
+          <a:p>
+            <a:endParaRPr lang="en-US" sz="1200" b="1" i="0" kern="1200" dirty="0">
+              <a:solidFill>
+                <a:schemeClr val="tx1"/>
+              </a:solidFill>
+              <a:effectLst/>
+              <a:latin typeface="+mn-lt"/>
+              <a:ea typeface="+mn-ea"/>
+              <a:cs typeface="+mn-cs"/>
+            </a:endParaRPr>
+          </a:p>
+          <a:p>
+            <a:pPr marL="0" marR="0" lvl="0" indent="0" algn="l" defTabSz="914400" rtl="0" eaLnBrk="1" fontAlgn="auto" latinLnBrk="0" hangingPunct="1">
+              <a:lnSpc>
+                <a:spcPct val="100000"/>
+              </a:lnSpc>
+              <a:spcBef>
+                <a:spcPts val="0"/>
+              </a:spcBef>
+              <a:spcAft>
+                <a:spcPts val="0"/>
+              </a:spcAft>
+              <a:buClrTx/>
+              <a:buSzTx/>
+              <a:buFontTx/>
+              <a:buNone/>
+              <a:tabLst/>
+              <a:defRPr/>
+            </a:pPr>
+            <a:r>
+              <a:rPr lang="en-US" sz="1200" b="0" i="0" kern="1200" dirty="0">
+                <a:solidFill>
+                  <a:schemeClr val="tx1"/>
+                </a:solidFill>
+                <a:effectLst/>
+                <a:latin typeface="+mn-lt"/>
+                <a:ea typeface="+mn-ea"/>
+                <a:cs typeface="+mn-cs"/>
+              </a:rPr>
+              <a:t>Columns with at least one missing value: </a:t>
+            </a:r>
+            <a:r>
+              <a:rPr lang="en-US" sz="1200" b="1" i="0" kern="1200" dirty="0">
+                <a:solidFill>
+                  <a:schemeClr val="tx1"/>
+                </a:solidFill>
+                <a:effectLst/>
+                <a:latin typeface="+mn-lt"/>
+                <a:ea typeface="+mn-ea"/>
+                <a:cs typeface="+mn-cs"/>
+              </a:rPr>
+              <a:t>flights[</a:t>
+            </a:r>
+            <a:r>
+              <a:rPr lang="en-US" sz="1200" b="1" i="0" kern="1200" dirty="0" err="1">
+                <a:solidFill>
+                  <a:schemeClr val="tx1"/>
+                </a:solidFill>
+                <a:effectLst/>
+                <a:latin typeface="+mn-lt"/>
+                <a:ea typeface="+mn-ea"/>
+                <a:cs typeface="+mn-cs"/>
+              </a:rPr>
+              <a:t>flights.isnull</a:t>
+            </a:r>
+            <a:r>
+              <a:rPr lang="en-US" sz="1200" b="1" i="0" kern="1200" dirty="0">
+                <a:solidFill>
+                  <a:schemeClr val="tx1"/>
+                </a:solidFill>
+                <a:effectLst/>
+                <a:latin typeface="+mn-lt"/>
+                <a:ea typeface="+mn-ea"/>
+                <a:cs typeface="+mn-cs"/>
+              </a:rPr>
+              <a:t>().any(axis=0)]</a:t>
+            </a:r>
+          </a:p>
+          <a:p>
+            <a:pPr marL="171450" marR="0" lvl="0" indent="-171450" algn="l" defTabSz="914400" rtl="0" eaLnBrk="1" fontAlgn="auto" latinLnBrk="0" hangingPunct="1">
+              <a:lnSpc>
+                <a:spcPct val="100000"/>
+              </a:lnSpc>
+              <a:spcBef>
+                <a:spcPts val="0"/>
+              </a:spcBef>
+              <a:spcAft>
+                <a:spcPts val="0"/>
+              </a:spcAft>
+              <a:buClrTx/>
+              <a:buSzTx/>
+              <a:buFont typeface="Arial" panose="020B0604020202020204" pitchFamily="34" charset="0"/>
+              <a:buChar char="•"/>
+              <a:tabLst/>
+              <a:defRPr/>
+            </a:pPr>
+            <a:r>
+              <a:rPr lang="en-US" sz="1200" b="0" i="0" kern="1200" dirty="0">
+                <a:solidFill>
+                  <a:schemeClr val="tx1"/>
+                </a:solidFill>
+                <a:effectLst/>
+                <a:latin typeface="+mn-lt"/>
+                <a:ea typeface="+mn-ea"/>
+                <a:cs typeface="+mn-cs"/>
+              </a:rPr>
+              <a:t>Use axis=0 to filter columns based on missing data.</a:t>
+            </a:r>
+          </a:p>
+          <a:p>
+            <a:pPr marL="0" marR="0" lvl="0" indent="0" algn="l" defTabSz="914400" rtl="0" eaLnBrk="1" fontAlgn="auto" latinLnBrk="0" hangingPunct="1">
+              <a:lnSpc>
+                <a:spcPct val="100000"/>
+              </a:lnSpc>
+              <a:spcBef>
+                <a:spcPts val="0"/>
+              </a:spcBef>
+              <a:spcAft>
+                <a:spcPts val="0"/>
+              </a:spcAft>
+              <a:buClrTx/>
+              <a:buSzTx/>
+              <a:buFontTx/>
+              <a:buNone/>
+              <a:tabLst/>
+              <a:defRPr/>
+            </a:pPr>
+            <a:endParaRPr lang="de-DE" b="1" dirty="0"/>
+          </a:p>
+        </p:txBody>
+      </p:sp>
+      <p:sp>
+        <p:nvSpPr>
+          <p:cNvPr id="4" name="Foliennummernplatzhalter 3"/>
+          <p:cNvSpPr>
+            <a:spLocks noGrp="1"/>
+          </p:cNvSpPr>
+          <p:nvPr>
+            <p:ph type="sldNum" sz="quarter" idx="5"/>
+          </p:nvPr>
+        </p:nvSpPr>
+        <p:spPr/>
+        <p:txBody>
+          <a:bodyPr/>
+          <a:lstStyle/>
+          <a:p>
+            <a:fld id="{1C35B555-7100-4285-9AD5-4C99DEA7ECE6}" type="slidenum">
+              <a:rPr lang="en-US" smtClean="0"/>
+              <a:t>35</a:t>
+            </a:fld>
+            <a:endParaRPr lang="en-US"/>
+          </a:p>
+        </p:txBody>
+      </p:sp>
+    </p:spTree>
+    <p:extLst>
+      <p:ext uri="{BB962C8B-B14F-4D97-AF65-F5344CB8AC3E}">
+        <p14:creationId xmlns:p14="http://schemas.microsoft.com/office/powerpoint/2010/main" val="10006870"/>
+      </p:ext>
+    </p:extLst>
+  </p:cSld>
+  <p:clrMapOvr>
+    <a:masterClrMapping/>
+  </p:clrMapOvr>
+</p:notes>
+</file>
+
+<file path=ppt/notesSlides/notesSlide5.xml><?xml version="1.0" encoding="utf-8"?>
+<p:notes xmlns:a="http://schemas.openxmlformats.org/drawingml/2006/main" xmlns:r="http://schemas.openxmlformats.org/officeDocument/2006/relationships" xmlns:p="http://schemas.openxmlformats.org/presentationml/2006/main">
+  <p:cSld>
+    <p:spTree>
+      <p:nvGrpSpPr>
+        <p:cNvPr id="1" name="">
+          <a:extLst>
+            <a:ext uri="{FF2B5EF4-FFF2-40B4-BE49-F238E27FC236}">
+              <a16:creationId xmlns:a16="http://schemas.microsoft.com/office/drawing/2014/main" id="{759AEFBD-31CB-0248-F40C-DC81CF415C6D}"/>
+            </a:ext>
+          </a:extLst>
+        </p:cNvPr>
+        <p:cNvGrpSpPr/>
+        <p:nvPr/>
+      </p:nvGrpSpPr>
+      <p:grpSpPr>
+        <a:xfrm>
+          <a:off x="0" y="0"/>
+          <a:ext cx="0" cy="0"/>
+          <a:chOff x="0" y="0"/>
+          <a:chExt cx="0" cy="0"/>
+        </a:xfrm>
+      </p:grpSpPr>
+      <p:sp>
+        <p:nvSpPr>
+          <p:cNvPr id="2" name="Folienbildplatzhalter 1">
+            <a:extLst>
+              <a:ext uri="{FF2B5EF4-FFF2-40B4-BE49-F238E27FC236}">
+                <a16:creationId xmlns:a16="http://schemas.microsoft.com/office/drawing/2014/main" id="{12880386-33D1-40A1-FABD-35C3DBBEF40F}"/>
+              </a:ext>
+            </a:extLst>
+          </p:cNvPr>
+          <p:cNvSpPr>
+            <a:spLocks noGrp="1" noRot="1" noChangeAspect="1"/>
+          </p:cNvSpPr>
+          <p:nvPr>
+            <p:ph type="sldImg"/>
+          </p:nvPr>
+        </p:nvSpPr>
+        <p:spPr/>
+      </p:sp>
+      <p:sp>
+        <p:nvSpPr>
+          <p:cNvPr id="3" name="Notizenplatzhalter 2">
+            <a:extLst>
+              <a:ext uri="{FF2B5EF4-FFF2-40B4-BE49-F238E27FC236}">
+                <a16:creationId xmlns:a16="http://schemas.microsoft.com/office/drawing/2014/main" id="{3C3502FC-F190-356E-91CB-71BFBF39DC12}"/>
+              </a:ext>
+            </a:extLst>
+          </p:cNvPr>
+          <p:cNvSpPr>
+            <a:spLocks noGrp="1"/>
+          </p:cNvSpPr>
+          <p:nvPr>
+            <p:ph type="body" idx="1"/>
+          </p:nvPr>
+        </p:nvSpPr>
+        <p:spPr/>
+        <p:txBody>
+          <a:bodyPr/>
+          <a:lstStyle/>
+          <a:p>
+            <a:pPr>
+              <a:lnSpc>
+                <a:spcPct val="150000"/>
+              </a:lnSpc>
+            </a:pPr>
+            <a:r>
+              <a:rPr lang="en-US" sz="1400" b="0" i="0" kern="1200" dirty="0">
+                <a:solidFill>
+                  <a:schemeClr val="tx1"/>
+                </a:solidFill>
+                <a:effectLst/>
+                <a:latin typeface="+mn-lt"/>
+                <a:ea typeface="+mn-ea"/>
+                <a:cs typeface="+mn-cs"/>
+              </a:rPr>
+              <a:t>The code snippet displays the first five rows in the </a:t>
+            </a:r>
+            <a:r>
+              <a:rPr lang="en-US" sz="1400" b="0" i="0" kern="1200" dirty="0" err="1">
+                <a:solidFill>
+                  <a:schemeClr val="tx1"/>
+                </a:solidFill>
+                <a:effectLst/>
+                <a:latin typeface="+mn-lt"/>
+                <a:ea typeface="+mn-ea"/>
+                <a:cs typeface="+mn-cs"/>
+              </a:rPr>
+              <a:t>DataFrame</a:t>
+            </a:r>
+            <a:r>
+              <a:rPr lang="en-US" sz="1400" b="0" i="0" kern="1200" dirty="0">
+                <a:solidFill>
+                  <a:schemeClr val="tx1"/>
+                </a:solidFill>
+                <a:effectLst/>
+                <a:latin typeface="+mn-lt"/>
+                <a:ea typeface="+mn-ea"/>
+                <a:cs typeface="+mn-cs"/>
+              </a:rPr>
+              <a:t> flights that contain at least one missing (null/</a:t>
+            </a:r>
+            <a:r>
+              <a:rPr lang="en-US" sz="1400" b="0" i="0" kern="1200" dirty="0" err="1">
+                <a:solidFill>
+                  <a:schemeClr val="tx1"/>
+                </a:solidFill>
+                <a:effectLst/>
+                <a:latin typeface="+mn-lt"/>
+                <a:ea typeface="+mn-ea"/>
+                <a:cs typeface="+mn-cs"/>
+              </a:rPr>
+              <a:t>NaN</a:t>
+            </a:r>
+            <a:r>
+              <a:rPr lang="en-US" sz="1400" b="0" i="0" kern="1200" dirty="0">
+                <a:solidFill>
+                  <a:schemeClr val="tx1"/>
+                </a:solidFill>
+                <a:effectLst/>
+                <a:latin typeface="+mn-lt"/>
+                <a:ea typeface="+mn-ea"/>
+                <a:cs typeface="+mn-cs"/>
+              </a:rPr>
+              <a:t>) value.</a:t>
+            </a:r>
+          </a:p>
+          <a:p>
+            <a:pPr>
+              <a:lnSpc>
+                <a:spcPct val="150000"/>
+              </a:lnSpc>
+            </a:pPr>
+            <a:r>
+              <a:rPr lang="en-US" sz="1400" b="0" i="0" kern="1200" dirty="0">
+                <a:solidFill>
+                  <a:schemeClr val="tx1"/>
+                </a:solidFill>
+                <a:effectLst/>
+                <a:latin typeface="+mn-lt"/>
+                <a:ea typeface="+mn-ea"/>
+                <a:cs typeface="+mn-cs"/>
+              </a:rPr>
+              <a:t>Code Behavior Explained</a:t>
+            </a:r>
+          </a:p>
+          <a:p>
+            <a:pPr marL="171450" indent="-171450">
+              <a:lnSpc>
+                <a:spcPct val="150000"/>
+              </a:lnSpc>
+              <a:buFont typeface="Arial" panose="020B0604020202020204" pitchFamily="34" charset="0"/>
+              <a:buChar char="•"/>
+            </a:pPr>
+            <a:r>
+              <a:rPr lang="en-US" sz="1400" b="0" i="0" kern="1200" dirty="0" err="1">
+                <a:solidFill>
+                  <a:schemeClr val="tx1"/>
+                </a:solidFill>
+                <a:effectLst/>
+                <a:latin typeface="+mn-lt"/>
+                <a:ea typeface="+mn-ea"/>
+                <a:cs typeface="+mn-cs"/>
+              </a:rPr>
+              <a:t>flights.isnull</a:t>
+            </a:r>
+            <a:r>
+              <a:rPr lang="en-US" sz="1400" b="0" i="0" kern="1200" dirty="0">
+                <a:solidFill>
+                  <a:schemeClr val="tx1"/>
+                </a:solidFill>
+                <a:effectLst/>
+                <a:latin typeface="+mn-lt"/>
+                <a:ea typeface="+mn-ea"/>
+                <a:cs typeface="+mn-cs"/>
+              </a:rPr>
+              <a:t>() returns a Boolean </a:t>
+            </a:r>
+            <a:r>
+              <a:rPr lang="en-US" sz="1400" b="0" i="0" kern="1200" dirty="0" err="1">
+                <a:solidFill>
+                  <a:schemeClr val="tx1"/>
+                </a:solidFill>
+                <a:effectLst/>
+                <a:latin typeface="+mn-lt"/>
+                <a:ea typeface="+mn-ea"/>
+                <a:cs typeface="+mn-cs"/>
+              </a:rPr>
+              <a:t>DataFrame</a:t>
+            </a:r>
+            <a:r>
+              <a:rPr lang="en-US" sz="1400" b="0" i="0" kern="1200" dirty="0">
+                <a:solidFill>
+                  <a:schemeClr val="tx1"/>
+                </a:solidFill>
+                <a:effectLst/>
+                <a:latin typeface="+mn-lt"/>
+                <a:ea typeface="+mn-ea"/>
+                <a:cs typeface="+mn-cs"/>
+              </a:rPr>
+              <a:t> indicating which cells are null.</a:t>
+            </a:r>
+          </a:p>
+          <a:p>
+            <a:pPr marL="171450" indent="-171450">
+              <a:lnSpc>
+                <a:spcPct val="150000"/>
+              </a:lnSpc>
+              <a:buFont typeface="Arial" panose="020B0604020202020204" pitchFamily="34" charset="0"/>
+              <a:buChar char="•"/>
+            </a:pPr>
+            <a:r>
+              <a:rPr lang="en-US" sz="1400" b="0" i="0" kern="1200" dirty="0">
+                <a:solidFill>
+                  <a:schemeClr val="tx1"/>
+                </a:solidFill>
+                <a:effectLst/>
+                <a:latin typeface="+mn-lt"/>
+                <a:ea typeface="+mn-ea"/>
+                <a:cs typeface="+mn-cs"/>
+              </a:rPr>
+              <a:t>.any(axis=1) checks if any value in each row is null.</a:t>
+            </a:r>
+          </a:p>
+          <a:p>
+            <a:pPr marL="171450" indent="-171450">
+              <a:lnSpc>
+                <a:spcPct val="150000"/>
+              </a:lnSpc>
+              <a:buFont typeface="Arial" panose="020B0604020202020204" pitchFamily="34" charset="0"/>
+              <a:buChar char="•"/>
+            </a:pPr>
+            <a:r>
+              <a:rPr lang="en-US" sz="1400" b="0" i="0" kern="1200" dirty="0">
+                <a:solidFill>
+                  <a:schemeClr val="tx1"/>
+                </a:solidFill>
+                <a:effectLst/>
+                <a:latin typeface="+mn-lt"/>
+                <a:ea typeface="+mn-ea"/>
+                <a:cs typeface="+mn-cs"/>
+              </a:rPr>
+              <a:t>flights[...] selects only those rows where the condition is True (i.e., rows with at least one null value).</a:t>
+            </a:r>
+          </a:p>
+          <a:p>
+            <a:pPr marL="171450" indent="-171450">
+              <a:lnSpc>
+                <a:spcPct val="150000"/>
+              </a:lnSpc>
+              <a:buFont typeface="Arial" panose="020B0604020202020204" pitchFamily="34" charset="0"/>
+              <a:buChar char="•"/>
+            </a:pPr>
+            <a:r>
+              <a:rPr lang="en-US" sz="1400" b="0" i="0" kern="1200" dirty="0">
+                <a:solidFill>
+                  <a:schemeClr val="tx1"/>
+                </a:solidFill>
+                <a:effectLst/>
+                <a:latin typeface="+mn-lt"/>
+                <a:ea typeface="+mn-ea"/>
+                <a:cs typeface="+mn-cs"/>
+              </a:rPr>
+              <a:t>.head() shows the first five of these rows.</a:t>
+            </a:r>
+          </a:p>
+          <a:p>
+            <a:pPr marL="0" indent="0">
+              <a:lnSpc>
+                <a:spcPct val="150000"/>
+              </a:lnSpc>
+              <a:buFont typeface="Arial" panose="020B0604020202020204" pitchFamily="34" charset="0"/>
+              <a:buNone/>
+            </a:pPr>
+            <a:r>
+              <a:rPr lang="en-US" sz="1400" b="0" i="0" kern="1200" dirty="0">
+                <a:solidFill>
+                  <a:schemeClr val="tx1"/>
+                </a:solidFill>
+                <a:effectLst/>
+                <a:latin typeface="+mn-lt"/>
+                <a:ea typeface="+mn-ea"/>
+                <a:cs typeface="+mn-cs"/>
+              </a:rPr>
+              <a:t>This is a common data inspection technique used for quickly identifying and previewing incomplete or missing data in a pandas </a:t>
+            </a:r>
+            <a:r>
+              <a:rPr lang="en-US" sz="1400" b="0" i="0" kern="1200" dirty="0" err="1">
+                <a:solidFill>
+                  <a:schemeClr val="tx1"/>
+                </a:solidFill>
+                <a:effectLst/>
+                <a:latin typeface="+mn-lt"/>
+                <a:ea typeface="+mn-ea"/>
+                <a:cs typeface="+mn-cs"/>
+              </a:rPr>
+              <a:t>DataFrame</a:t>
+            </a:r>
+            <a:r>
+              <a:rPr lang="en-US" sz="1400" b="0" i="0" kern="1200" dirty="0">
+                <a:solidFill>
+                  <a:schemeClr val="tx1"/>
+                </a:solidFill>
+                <a:effectLst/>
+                <a:latin typeface="+mn-lt"/>
+                <a:ea typeface="+mn-ea"/>
+                <a:cs typeface="+mn-cs"/>
+              </a:rPr>
+              <a:t>.</a:t>
+            </a:r>
+          </a:p>
+          <a:p>
+            <a:endParaRPr lang="de-DE" dirty="0"/>
+          </a:p>
+        </p:txBody>
+      </p:sp>
+      <p:sp>
+        <p:nvSpPr>
+          <p:cNvPr id="4" name="Foliennummernplatzhalter 3">
+            <a:extLst>
+              <a:ext uri="{FF2B5EF4-FFF2-40B4-BE49-F238E27FC236}">
+                <a16:creationId xmlns:a16="http://schemas.microsoft.com/office/drawing/2014/main" id="{3A353C38-4CA9-376D-44CF-CFE0B4324707}"/>
+              </a:ext>
+            </a:extLst>
+          </p:cNvPr>
+          <p:cNvSpPr>
+            <a:spLocks noGrp="1"/>
+          </p:cNvSpPr>
+          <p:nvPr>
+            <p:ph type="sldNum" sz="quarter" idx="5"/>
+          </p:nvPr>
+        </p:nvSpPr>
+        <p:spPr/>
+        <p:txBody>
+          <a:bodyPr/>
+          <a:lstStyle/>
+          <a:p>
+            <a:fld id="{1C35B555-7100-4285-9AD5-4C99DEA7ECE6}" type="slidenum">
+              <a:rPr lang="en-US" smtClean="0"/>
+              <a:t>36</a:t>
+            </a:fld>
+            <a:endParaRPr lang="en-US"/>
+          </a:p>
+        </p:txBody>
+      </p:sp>
+    </p:spTree>
+    <p:extLst>
+      <p:ext uri="{BB962C8B-B14F-4D97-AF65-F5344CB8AC3E}">
+        <p14:creationId xmlns:p14="http://schemas.microsoft.com/office/powerpoint/2010/main" val="1997581500"/>
+      </p:ext>
+    </p:extLst>
+  </p:cSld>
+  <p:clrMapOvr>
+    <a:masterClrMapping/>
+  </p:clrMapOvr>
+</p:notes>
+</file>
+
 <file path=ppt/slideLayouts/slideLayout1.xml><?xml version="1.0" encoding="utf-8"?>
 <p:sldLayout xmlns:a="http://schemas.openxmlformats.org/drawingml/2006/main" xmlns:r="http://schemas.openxmlformats.org/officeDocument/2006/relationships" xmlns:p="http://schemas.openxmlformats.org/presentationml/2006/main" type="title" preserve="1">
   <p:cSld name="Title Slide">
@@ -910,7 +1561,7 @@
           <a:p>
             <a:fld id="{350E461F-61FE-4D81-8611-0097AAEF7B68}" type="datetime1">
               <a:rPr lang="en-US" smtClean="0"/>
-              <a:t>11/5/2025</a:t>
+              <a:t>11/12/2025</a:t>
             </a:fld>
             <a:endParaRPr lang="en-US"/>
           </a:p>
@@ -952,7 +1603,7 @@
           <a:p>
             <a:fld id="{B841CA95-E0BC-48B5-948A-ECC494EB4D84}" type="slidenum">
               <a:rPr lang="en-US" smtClean="0"/>
-              <a:t>‹#›</a:t>
+              <a:t>‹Nr.›</a:t>
             </a:fld>
             <a:endParaRPr lang="en-US"/>
           </a:p>
@@ -1078,7 +1729,7 @@
           <a:p>
             <a:fld id="{EC93E650-B1F9-41B7-A814-30DF5D824348}" type="datetime1">
               <a:rPr lang="en-US" smtClean="0"/>
-              <a:t>11/5/2025</a:t>
+              <a:t>11/12/2025</a:t>
             </a:fld>
             <a:endParaRPr lang="en-US"/>
           </a:p>
@@ -1120,7 +1771,7 @@
           <a:p>
             <a:fld id="{B841CA95-E0BC-48B5-948A-ECC494EB4D84}" type="slidenum">
               <a:rPr lang="en-US" smtClean="0"/>
-              <a:t>‹#›</a:t>
+              <a:t>‹Nr.›</a:t>
             </a:fld>
             <a:endParaRPr lang="en-US"/>
           </a:p>
@@ -1256,7 +1907,7 @@
           <a:p>
             <a:fld id="{73C66AA3-ECFC-423D-9D1F-F2B307D4D685}" type="datetime1">
               <a:rPr lang="en-US" smtClean="0"/>
-              <a:t>11/5/2025</a:t>
+              <a:t>11/12/2025</a:t>
             </a:fld>
             <a:endParaRPr lang="en-US"/>
           </a:p>
@@ -1298,7 +1949,7 @@
           <a:p>
             <a:fld id="{B841CA95-E0BC-48B5-948A-ECC494EB4D84}" type="slidenum">
               <a:rPr lang="en-US" smtClean="0"/>
-              <a:t>‹#›</a:t>
+              <a:t>‹Nr.›</a:t>
             </a:fld>
             <a:endParaRPr lang="en-US"/>
           </a:p>
@@ -1725,7 +2376,7 @@
           <a:p>
             <a:fld id="{74946075-E8DF-4742-8C24-79E95A67D237}" type="datetime1">
               <a:rPr lang="en-US" smtClean="0"/>
-              <a:t>11/5/2025</a:t>
+              <a:t>11/12/2025</a:t>
             </a:fld>
             <a:endParaRPr lang="en-US"/>
           </a:p>
@@ -1767,7 +2418,7 @@
           <a:p>
             <a:fld id="{B841CA95-E0BC-48B5-948A-ECC494EB4D84}" type="slidenum">
               <a:rPr lang="en-US" smtClean="0"/>
-              <a:t>‹#›</a:t>
+              <a:t>‹Nr.›</a:t>
             </a:fld>
             <a:endParaRPr lang="en-US"/>
           </a:p>
@@ -1970,7 +2621,7 @@
           <a:p>
             <a:fld id="{7B0B2289-7CF1-4619-A455-B0B4017B374E}" type="datetime1">
               <a:rPr lang="en-US" smtClean="0"/>
-              <a:t>11/5/2025</a:t>
+              <a:t>11/12/2025</a:t>
             </a:fld>
             <a:endParaRPr lang="en-US"/>
           </a:p>
@@ -2012,7 +2663,7 @@
           <a:p>
             <a:fld id="{B841CA95-E0BC-48B5-948A-ECC494EB4D84}" type="slidenum">
               <a:rPr lang="en-US" smtClean="0"/>
-              <a:t>‹#›</a:t>
+              <a:t>‹Nr.›</a:t>
             </a:fld>
             <a:endParaRPr lang="en-US"/>
           </a:p>
@@ -2199,7 +2850,7 @@
           <a:p>
             <a:fld id="{E94FDEA8-FDD0-47AB-9B1E-6412E7EC60D7}" type="datetime1">
               <a:rPr lang="en-US" smtClean="0"/>
-              <a:t>11/5/2025</a:t>
+              <a:t>11/12/2025</a:t>
             </a:fld>
             <a:endParaRPr lang="en-US"/>
           </a:p>
@@ -2241,7 +2892,7 @@
           <a:p>
             <a:fld id="{B841CA95-E0BC-48B5-948A-ECC494EB4D84}" type="slidenum">
               <a:rPr lang="en-US" smtClean="0"/>
-              <a:t>‹#›</a:t>
+              <a:t>‹Nr.›</a:t>
             </a:fld>
             <a:endParaRPr lang="en-US"/>
           </a:p>
@@ -2563,7 +3214,7 @@
           <a:p>
             <a:fld id="{7957D6ED-9C9A-4467-8EC7-039C0829B3DE}" type="datetime1">
               <a:rPr lang="en-US" smtClean="0"/>
-              <a:t>11/5/2025</a:t>
+              <a:t>11/12/2025</a:t>
             </a:fld>
             <a:endParaRPr lang="en-US"/>
           </a:p>
@@ -2605,7 +3256,7 @@
           <a:p>
             <a:fld id="{B841CA95-E0BC-48B5-948A-ECC494EB4D84}" type="slidenum">
               <a:rPr lang="en-US" smtClean="0"/>
-              <a:t>‹#›</a:t>
+              <a:t>‹Nr.›</a:t>
             </a:fld>
             <a:endParaRPr lang="en-US"/>
           </a:p>
@@ -2680,7 +3331,7 @@
           <a:p>
             <a:fld id="{5D9C30DE-6A64-4BEE-8EF3-DF084BEA05C1}" type="datetime1">
               <a:rPr lang="en-US" smtClean="0"/>
-              <a:t>11/5/2025</a:t>
+              <a:t>11/12/2025</a:t>
             </a:fld>
             <a:endParaRPr lang="en-US"/>
           </a:p>
@@ -2722,7 +3373,7 @@
           <a:p>
             <a:fld id="{B841CA95-E0BC-48B5-948A-ECC494EB4D84}" type="slidenum">
               <a:rPr lang="en-US" smtClean="0"/>
-              <a:t>‹#›</a:t>
+              <a:t>‹Nr.›</a:t>
             </a:fld>
             <a:endParaRPr lang="en-US"/>
           </a:p>
@@ -2775,7 +3426,7 @@
           <a:p>
             <a:fld id="{8CB4CAAF-2F01-498F-89B0-DB7EA8EC2343}" type="datetime1">
               <a:rPr lang="en-US" smtClean="0"/>
-              <a:t>11/5/2025</a:t>
+              <a:t>11/12/2025</a:t>
             </a:fld>
             <a:endParaRPr lang="en-US"/>
           </a:p>
@@ -2817,7 +3468,7 @@
           <a:p>
             <a:fld id="{B841CA95-E0BC-48B5-948A-ECC494EB4D84}" type="slidenum">
               <a:rPr lang="en-US" smtClean="0"/>
-              <a:t>‹#›</a:t>
+              <a:t>‹Nr.›</a:t>
             </a:fld>
             <a:endParaRPr lang="en-US"/>
           </a:p>
@@ -3050,7 +3701,7 @@
           <a:p>
             <a:fld id="{4F10F7E6-27E1-42EF-8BDB-5661503F4C2D}" type="datetime1">
               <a:rPr lang="en-US" smtClean="0"/>
-              <a:t>11/5/2025</a:t>
+              <a:t>11/12/2025</a:t>
             </a:fld>
             <a:endParaRPr lang="en-US"/>
           </a:p>
@@ -3092,7 +3743,7 @@
           <a:p>
             <a:fld id="{B841CA95-E0BC-48B5-948A-ECC494EB4D84}" type="slidenum">
               <a:rPr lang="en-US" smtClean="0"/>
-              <a:t>‹#›</a:t>
+              <a:t>‹Nr.›</a:t>
             </a:fld>
             <a:endParaRPr lang="en-US"/>
           </a:p>
@@ -3302,7 +3953,7 @@
           <a:p>
             <a:fld id="{04F16676-04F5-493E-A02A-6B73A4AE7951}" type="datetime1">
               <a:rPr lang="en-US" smtClean="0"/>
-              <a:t>11/5/2025</a:t>
+              <a:t>11/12/2025</a:t>
             </a:fld>
             <a:endParaRPr lang="en-US"/>
           </a:p>
@@ -3344,7 +3995,7 @@
           <a:p>
             <a:fld id="{B841CA95-E0BC-48B5-948A-ECC494EB4D84}" type="slidenum">
               <a:rPr lang="en-US" smtClean="0"/>
-              <a:t>‹#›</a:t>
+              <a:t>‹Nr.›</a:t>
             </a:fld>
             <a:endParaRPr lang="en-US"/>
           </a:p>
@@ -3513,7 +4164,7 @@
           <a:p>
             <a:fld id="{A0969F45-234F-4D98-8AAE-7ED1F80960E9}" type="datetime1">
               <a:rPr lang="en-US" smtClean="0"/>
-              <a:t>11/5/2025</a:t>
+              <a:t>11/12/2025</a:t>
             </a:fld>
             <a:endParaRPr lang="en-US"/>
           </a:p>
@@ -3591,7 +4242,7 @@
           <a:p>
             <a:fld id="{B841CA95-E0BC-48B5-948A-ECC494EB4D84}" type="slidenum">
               <a:rPr lang="en-US" smtClean="0"/>
-              <a:t>‹#›</a:t>
+              <a:t>‹Nr.›</a:t>
             </a:fld>
             <a:endParaRPr lang="en-US"/>
           </a:p>
@@ -16598,7 +17249,7 @@
                 <a:latin typeface="Courier New" panose="02070309020205020404" pitchFamily="49" charset="0"/>
                 <a:cs typeface="Courier New" panose="02070309020205020404" pitchFamily="49" charset="0"/>
               </a:rPr>
-              <a:t>data_analysis</a:t>
+              <a:t>DataAnalysis</a:t>
             </a:r>
             <a:r>
               <a:rPr lang="en-US" sz="1600" dirty="0">
@@ -16810,7 +17461,7 @@
           <p:nvPr/>
         </p:nvPicPr>
         <p:blipFill>
-          <a:blip r:embed="rId2">
+          <a:blip r:embed="rId3">
             <a:extLst>
               <a:ext uri="{28A0092B-C50C-407E-A947-70E740481C1C}">
                 <a14:useLocalDpi xmlns:a14="http://schemas.microsoft.com/office/drawing/2010/main" val="0"/>
@@ -16849,6 +17500,633 @@
   <p:cSld>
     <p:spTree>
       <p:nvGrpSpPr>
+        <p:cNvPr id="1" name="">
+          <a:extLst>
+            <a:ext uri="{FF2B5EF4-FFF2-40B4-BE49-F238E27FC236}">
+              <a16:creationId xmlns:a16="http://schemas.microsoft.com/office/drawing/2014/main" id="{4359892D-BE47-BFE0-4751-8D05FA0FE72D}"/>
+            </a:ext>
+          </a:extLst>
+        </p:cNvPr>
+        <p:cNvGrpSpPr/>
+        <p:nvPr/>
+      </p:nvGrpSpPr>
+      <p:grpSpPr>
+        <a:xfrm>
+          <a:off x="0" y="0"/>
+          <a:ext cx="0" cy="0"/>
+          <a:chOff x="0" y="0"/>
+          <a:chExt cx="0" cy="0"/>
+        </a:xfrm>
+      </p:grpSpPr>
+      <p:sp>
+        <p:nvSpPr>
+          <p:cNvPr id="2" name="Title 1">
+            <a:extLst>
+              <a:ext uri="{FF2B5EF4-FFF2-40B4-BE49-F238E27FC236}">
+                <a16:creationId xmlns:a16="http://schemas.microsoft.com/office/drawing/2014/main" id="{02CC6B59-2682-B5A6-C642-AD51621FF8EF}"/>
+              </a:ext>
+            </a:extLst>
+          </p:cNvPr>
+          <p:cNvSpPr>
+            <a:spLocks noGrp="1"/>
+          </p:cNvSpPr>
+          <p:nvPr>
+            <p:ph type="title"/>
+          </p:nvPr>
+        </p:nvSpPr>
+        <p:spPr/>
+        <p:txBody>
+          <a:bodyPr/>
+          <a:lstStyle/>
+          <a:p>
+            <a:r>
+              <a:rPr lang="en-US" dirty="0"/>
+              <a:t>Missing Values</a:t>
+            </a:r>
+          </a:p>
+        </p:txBody>
+      </p:sp>
+      <p:sp>
+        <p:nvSpPr>
+          <p:cNvPr id="4" name="Slide Number Placeholder 3">
+            <a:extLst>
+              <a:ext uri="{FF2B5EF4-FFF2-40B4-BE49-F238E27FC236}">
+                <a16:creationId xmlns:a16="http://schemas.microsoft.com/office/drawing/2014/main" id="{7E556B86-C12B-1D73-36F2-5786440B1E37}"/>
+              </a:ext>
+            </a:extLst>
+          </p:cNvPr>
+          <p:cNvSpPr>
+            <a:spLocks noGrp="1"/>
+          </p:cNvSpPr>
+          <p:nvPr>
+            <p:ph type="sldNum" sz="quarter" idx="12"/>
+          </p:nvPr>
+        </p:nvSpPr>
+        <p:spPr/>
+        <p:txBody>
+          <a:bodyPr/>
+          <a:lstStyle/>
+          <a:p>
+            <a:fld id="{B841CA95-E0BC-48B5-948A-ECC494EB4D84}" type="slidenum">
+              <a:rPr lang="en-US" smtClean="0"/>
+              <a:t>36</a:t>
+            </a:fld>
+            <a:endParaRPr lang="en-US"/>
+          </a:p>
+        </p:txBody>
+      </p:sp>
+      <p:sp>
+        <p:nvSpPr>
+          <p:cNvPr id="7" name="TextBox 6">
+            <a:extLst>
+              <a:ext uri="{FF2B5EF4-FFF2-40B4-BE49-F238E27FC236}">
+                <a16:creationId xmlns:a16="http://schemas.microsoft.com/office/drawing/2014/main" id="{76821E04-183F-2DFF-5F04-585F28D2910E}"/>
+              </a:ext>
+            </a:extLst>
+          </p:cNvPr>
+          <p:cNvSpPr txBox="1"/>
+          <p:nvPr/>
+        </p:nvSpPr>
+        <p:spPr>
+          <a:xfrm>
+            <a:off x="991089" y="1770269"/>
+            <a:ext cx="10418164" cy="461665"/>
+          </a:xfrm>
+          <a:prstGeom prst="rect">
+            <a:avLst/>
+          </a:prstGeom>
+          <a:noFill/>
+        </p:spPr>
+        <p:txBody>
+          <a:bodyPr wrap="square" rtlCol="0">
+            <a:spAutoFit/>
+          </a:bodyPr>
+          <a:lstStyle/>
+          <a:p>
+            <a:r>
+              <a:rPr lang="en-US" sz="2400" dirty="0"/>
+              <a:t>Missing values are marked as </a:t>
+            </a:r>
+            <a:r>
+              <a:rPr lang="en-US" sz="2400" dirty="0" err="1"/>
+              <a:t>NaN</a:t>
+            </a:r>
+            <a:endParaRPr lang="en-US" sz="2400" dirty="0"/>
+          </a:p>
+        </p:txBody>
+      </p:sp>
+      <p:sp>
+        <p:nvSpPr>
+          <p:cNvPr id="8" name="TextBox 7">
+            <a:extLst>
+              <a:ext uri="{FF2B5EF4-FFF2-40B4-BE49-F238E27FC236}">
+                <a16:creationId xmlns:a16="http://schemas.microsoft.com/office/drawing/2014/main" id="{D5E30EE4-5B2B-A4B4-C56E-6E536E9199E5}"/>
+              </a:ext>
+            </a:extLst>
+          </p:cNvPr>
+          <p:cNvSpPr txBox="1"/>
+          <p:nvPr/>
+        </p:nvSpPr>
+        <p:spPr>
+          <a:xfrm>
+            <a:off x="-77533" y="2327049"/>
+            <a:ext cx="10846184" cy="369332"/>
+          </a:xfrm>
+          <a:prstGeom prst="rect">
+            <a:avLst/>
+          </a:prstGeom>
+          <a:noFill/>
+          <a:ln>
+            <a:noFill/>
+          </a:ln>
+        </p:spPr>
+        <p:txBody>
+          <a:bodyPr wrap="square" rtlCol="0">
+            <a:spAutoFit/>
+          </a:bodyPr>
+          <a:lstStyle/>
+          <a:p>
+            <a:r>
+              <a:rPr lang="en-US" dirty="0"/>
+              <a:t>         </a:t>
+            </a:r>
+            <a:r>
+              <a:rPr lang="en-US" sz="1600" dirty="0">
+                <a:solidFill>
+                  <a:schemeClr val="accent5">
+                    <a:lumMod val="75000"/>
+                  </a:schemeClr>
+                </a:solidFill>
+                <a:latin typeface="Courier New" panose="02070309020205020404" pitchFamily="49" charset="0"/>
+                <a:cs typeface="Courier New" panose="02070309020205020404" pitchFamily="49" charset="0"/>
+              </a:rPr>
+              <a:t>In [ ]:</a:t>
+            </a:r>
+          </a:p>
+        </p:txBody>
+      </p:sp>
+      <p:sp>
+        <p:nvSpPr>
+          <p:cNvPr id="11" name="TextBox 10">
+            <a:extLst>
+              <a:ext uri="{FF2B5EF4-FFF2-40B4-BE49-F238E27FC236}">
+                <a16:creationId xmlns:a16="http://schemas.microsoft.com/office/drawing/2014/main" id="{4A929DF2-CADC-AE8E-CD39-0C07E5F8AA1C}"/>
+              </a:ext>
+            </a:extLst>
+          </p:cNvPr>
+          <p:cNvSpPr txBox="1"/>
+          <p:nvPr/>
+        </p:nvSpPr>
+        <p:spPr>
+          <a:xfrm>
+            <a:off x="1368357" y="2327049"/>
+            <a:ext cx="10653925" cy="584775"/>
+          </a:xfrm>
+          <a:prstGeom prst="rect">
+            <a:avLst/>
+          </a:prstGeom>
+          <a:noFill/>
+          <a:ln>
+            <a:solidFill>
+              <a:schemeClr val="bg2">
+                <a:lumMod val="90000"/>
+              </a:schemeClr>
+            </a:solidFill>
+          </a:ln>
+        </p:spPr>
+        <p:txBody>
+          <a:bodyPr wrap="square" rtlCol="0">
+            <a:spAutoFit/>
+          </a:bodyPr>
+          <a:lstStyle/>
+          <a:p>
+            <a:r>
+              <a:rPr lang="en-US" sz="1600" dirty="0">
+                <a:solidFill>
+                  <a:schemeClr val="accent6">
+                    <a:lumMod val="75000"/>
+                  </a:schemeClr>
+                </a:solidFill>
+                <a:latin typeface="Courier New" panose="02070309020205020404" pitchFamily="49" charset="0"/>
+                <a:cs typeface="Courier New" panose="02070309020205020404" pitchFamily="49" charset="0"/>
+              </a:rPr>
+              <a:t># Read a dataset with missing values</a:t>
+            </a:r>
+          </a:p>
+          <a:p>
+            <a:r>
+              <a:rPr lang="en-US" sz="1600" dirty="0">
+                <a:solidFill>
+                  <a:schemeClr val="bg2">
+                    <a:lumMod val="25000"/>
+                  </a:schemeClr>
+                </a:solidFill>
+                <a:latin typeface="Courier New" panose="02070309020205020404" pitchFamily="49" charset="0"/>
+                <a:cs typeface="Courier New" panose="02070309020205020404" pitchFamily="49" charset="0"/>
+              </a:rPr>
+              <a:t>flights = </a:t>
+            </a:r>
+            <a:r>
+              <a:rPr lang="en-US" sz="1600" dirty="0" err="1">
+                <a:solidFill>
+                  <a:schemeClr val="bg2">
+                    <a:lumMod val="25000"/>
+                  </a:schemeClr>
+                </a:solidFill>
+                <a:latin typeface="Courier New" panose="02070309020205020404" pitchFamily="49" charset="0"/>
+                <a:cs typeface="Courier New" panose="02070309020205020404" pitchFamily="49" charset="0"/>
+              </a:rPr>
+              <a:t>pd.read_csv</a:t>
+            </a:r>
+            <a:r>
+              <a:rPr lang="en-US" sz="1600" dirty="0">
+                <a:solidFill>
+                  <a:schemeClr val="bg2">
+                    <a:lumMod val="25000"/>
+                  </a:schemeClr>
+                </a:solidFill>
+                <a:latin typeface="Courier New" panose="02070309020205020404" pitchFamily="49" charset="0"/>
+                <a:cs typeface="Courier New" panose="02070309020205020404" pitchFamily="49" charset="0"/>
+              </a:rPr>
+              <a:t>(</a:t>
+            </a:r>
+            <a:r>
+              <a:rPr lang="en-US" sz="1600" dirty="0">
+                <a:solidFill>
+                  <a:srgbClr val="C00000"/>
+                </a:solidFill>
+                <a:latin typeface="Courier New" panose="02070309020205020404" pitchFamily="49" charset="0"/>
+                <a:cs typeface="Courier New" panose="02070309020205020404" pitchFamily="49" charset="0"/>
+              </a:rPr>
+              <a:t>"http://rcs.bu.edu/examples/python/</a:t>
+            </a:r>
+            <a:r>
+              <a:rPr lang="en-US" sz="1600" dirty="0" err="1">
+                <a:solidFill>
+                  <a:srgbClr val="C00000"/>
+                </a:solidFill>
+                <a:latin typeface="Courier New" panose="02070309020205020404" pitchFamily="49" charset="0"/>
+                <a:cs typeface="Courier New" panose="02070309020205020404" pitchFamily="49" charset="0"/>
+              </a:rPr>
+              <a:t>DataAnalysis</a:t>
+            </a:r>
+            <a:r>
+              <a:rPr lang="en-US" sz="1600" dirty="0">
+                <a:solidFill>
+                  <a:srgbClr val="C00000"/>
+                </a:solidFill>
+                <a:latin typeface="Courier New" panose="02070309020205020404" pitchFamily="49" charset="0"/>
+                <a:cs typeface="Courier New" panose="02070309020205020404" pitchFamily="49" charset="0"/>
+              </a:rPr>
+              <a:t>/flights.csv"</a:t>
+            </a:r>
+            <a:r>
+              <a:rPr lang="en-US" sz="1600" dirty="0">
+                <a:solidFill>
+                  <a:schemeClr val="bg2">
+                    <a:lumMod val="25000"/>
+                  </a:schemeClr>
+                </a:solidFill>
+                <a:latin typeface="Courier New" panose="02070309020205020404" pitchFamily="49" charset="0"/>
+                <a:cs typeface="Courier New" panose="02070309020205020404" pitchFamily="49" charset="0"/>
+              </a:rPr>
+              <a:t>)</a:t>
+            </a:r>
+            <a:endParaRPr lang="en-US" dirty="0">
+              <a:latin typeface="Courier New" panose="02070309020205020404" pitchFamily="49" charset="0"/>
+              <a:cs typeface="Courier New" panose="02070309020205020404" pitchFamily="49" charset="0"/>
+            </a:endParaRPr>
+          </a:p>
+        </p:txBody>
+      </p:sp>
+      <p:sp>
+        <p:nvSpPr>
+          <p:cNvPr id="9" name="TextBox 8">
+            <a:extLst>
+              <a:ext uri="{FF2B5EF4-FFF2-40B4-BE49-F238E27FC236}">
+                <a16:creationId xmlns:a16="http://schemas.microsoft.com/office/drawing/2014/main" id="{318173A7-6126-15FB-8216-28D9938AC9F1}"/>
+              </a:ext>
+            </a:extLst>
+          </p:cNvPr>
+          <p:cNvSpPr txBox="1"/>
+          <p:nvPr/>
+        </p:nvSpPr>
+        <p:spPr>
+          <a:xfrm>
+            <a:off x="-91389" y="3237992"/>
+            <a:ext cx="10846184" cy="369332"/>
+          </a:xfrm>
+          <a:prstGeom prst="rect">
+            <a:avLst/>
+          </a:prstGeom>
+          <a:noFill/>
+          <a:ln>
+            <a:noFill/>
+          </a:ln>
+        </p:spPr>
+        <p:txBody>
+          <a:bodyPr wrap="square" rtlCol="0">
+            <a:spAutoFit/>
+          </a:bodyPr>
+          <a:lstStyle/>
+          <a:p>
+            <a:r>
+              <a:rPr lang="en-US" dirty="0"/>
+              <a:t>         </a:t>
+            </a:r>
+            <a:r>
+              <a:rPr lang="en-US" sz="1600" dirty="0">
+                <a:solidFill>
+                  <a:schemeClr val="accent5">
+                    <a:lumMod val="75000"/>
+                  </a:schemeClr>
+                </a:solidFill>
+                <a:latin typeface="Courier New" panose="02070309020205020404" pitchFamily="49" charset="0"/>
+                <a:cs typeface="Courier New" panose="02070309020205020404" pitchFamily="49" charset="0"/>
+              </a:rPr>
+              <a:t>In [ ]:</a:t>
+            </a:r>
+          </a:p>
+        </p:txBody>
+      </p:sp>
+      <p:sp>
+        <p:nvSpPr>
+          <p:cNvPr id="10" name="TextBox 9">
+            <a:extLst>
+              <a:ext uri="{FF2B5EF4-FFF2-40B4-BE49-F238E27FC236}">
+                <a16:creationId xmlns:a16="http://schemas.microsoft.com/office/drawing/2014/main" id="{A3AC85F0-9F4B-CFDA-7552-21C24D50BECD}"/>
+              </a:ext>
+            </a:extLst>
+          </p:cNvPr>
+          <p:cNvSpPr txBox="1"/>
+          <p:nvPr/>
+        </p:nvSpPr>
+        <p:spPr>
+          <a:xfrm>
+            <a:off x="1354501" y="3237992"/>
+            <a:ext cx="10653925" cy="584775"/>
+          </a:xfrm>
+          <a:prstGeom prst="rect">
+            <a:avLst/>
+          </a:prstGeom>
+          <a:noFill/>
+          <a:ln>
+            <a:solidFill>
+              <a:schemeClr val="bg2">
+                <a:lumMod val="90000"/>
+              </a:schemeClr>
+            </a:solidFill>
+          </a:ln>
+        </p:spPr>
+        <p:txBody>
+          <a:bodyPr wrap="square" rtlCol="0">
+            <a:spAutoFit/>
+          </a:bodyPr>
+          <a:lstStyle/>
+          <a:p>
+            <a:r>
+              <a:rPr lang="en-US" sz="1600" dirty="0">
+                <a:solidFill>
+                  <a:schemeClr val="accent6">
+                    <a:lumMod val="75000"/>
+                  </a:schemeClr>
+                </a:solidFill>
+                <a:latin typeface="Courier New" panose="02070309020205020404" pitchFamily="49" charset="0"/>
+                <a:cs typeface="Courier New" panose="02070309020205020404" pitchFamily="49" charset="0"/>
+              </a:rPr>
+              <a:t># Select the rows that have at least one missing value</a:t>
+            </a:r>
+          </a:p>
+          <a:p>
+            <a:r>
+              <a:rPr lang="en-US" sz="1600" dirty="0">
+                <a:solidFill>
+                  <a:schemeClr val="bg2">
+                    <a:lumMod val="25000"/>
+                  </a:schemeClr>
+                </a:solidFill>
+                <a:latin typeface="Courier New" panose="02070309020205020404" pitchFamily="49" charset="0"/>
+                <a:cs typeface="Courier New" panose="02070309020205020404" pitchFamily="49" charset="0"/>
+              </a:rPr>
+              <a:t>flights[</a:t>
+            </a:r>
+            <a:r>
+              <a:rPr lang="en-US" sz="1600" dirty="0" err="1">
+                <a:solidFill>
+                  <a:schemeClr val="bg2">
+                    <a:lumMod val="25000"/>
+                  </a:schemeClr>
+                </a:solidFill>
+                <a:latin typeface="Courier New" panose="02070309020205020404" pitchFamily="49" charset="0"/>
+                <a:cs typeface="Courier New" panose="02070309020205020404" pitchFamily="49" charset="0"/>
+              </a:rPr>
+              <a:t>flights.isnull</a:t>
+            </a:r>
+            <a:r>
+              <a:rPr lang="en-US" sz="1600" dirty="0">
+                <a:solidFill>
+                  <a:schemeClr val="bg2">
+                    <a:lumMod val="25000"/>
+                  </a:schemeClr>
+                </a:solidFill>
+                <a:latin typeface="Courier New" panose="02070309020205020404" pitchFamily="49" charset="0"/>
+                <a:cs typeface="Courier New" panose="02070309020205020404" pitchFamily="49" charset="0"/>
+              </a:rPr>
+              <a:t>().any(axis=1)].head()</a:t>
+            </a:r>
+            <a:endParaRPr lang="en-US" dirty="0">
+              <a:latin typeface="Courier New" panose="02070309020205020404" pitchFamily="49" charset="0"/>
+              <a:cs typeface="Courier New" panose="02070309020205020404" pitchFamily="49" charset="0"/>
+            </a:endParaRPr>
+          </a:p>
+        </p:txBody>
+      </p:sp>
+      <p:sp>
+        <p:nvSpPr>
+          <p:cNvPr id="13" name="TextBox 12">
+            <a:extLst>
+              <a:ext uri="{FF2B5EF4-FFF2-40B4-BE49-F238E27FC236}">
+                <a16:creationId xmlns:a16="http://schemas.microsoft.com/office/drawing/2014/main" id="{826E4DA8-4F22-5C36-C1D8-45EB8FFA7104}"/>
+              </a:ext>
+            </a:extLst>
+          </p:cNvPr>
+          <p:cNvSpPr txBox="1"/>
+          <p:nvPr/>
+        </p:nvSpPr>
+        <p:spPr>
+          <a:xfrm>
+            <a:off x="-80036" y="3992320"/>
+            <a:ext cx="10846184" cy="369332"/>
+          </a:xfrm>
+          <a:prstGeom prst="rect">
+            <a:avLst/>
+          </a:prstGeom>
+          <a:noFill/>
+          <a:ln>
+            <a:noFill/>
+          </a:ln>
+        </p:spPr>
+        <p:txBody>
+          <a:bodyPr wrap="square" rtlCol="0">
+            <a:spAutoFit/>
+          </a:bodyPr>
+          <a:lstStyle/>
+          <a:p>
+            <a:r>
+              <a:rPr lang="en-US" dirty="0"/>
+              <a:t>         </a:t>
+            </a:r>
+            <a:r>
+              <a:rPr lang="en-US" sz="1600" dirty="0">
+                <a:solidFill>
+                  <a:srgbClr val="C00000"/>
+                </a:solidFill>
+                <a:latin typeface="Courier New" panose="02070309020205020404" pitchFamily="49" charset="0"/>
+                <a:cs typeface="Courier New" panose="02070309020205020404" pitchFamily="49" charset="0"/>
+              </a:rPr>
+              <a:t>Out[ ]:</a:t>
+            </a:r>
+          </a:p>
+        </p:txBody>
+      </p:sp>
+      <p:pic>
+        <p:nvPicPr>
+          <p:cNvPr id="3" name="Picture 2">
+            <a:extLst>
+              <a:ext uri="{FF2B5EF4-FFF2-40B4-BE49-F238E27FC236}">
+                <a16:creationId xmlns:a16="http://schemas.microsoft.com/office/drawing/2014/main" id="{2D5D5DBA-BB76-3B72-6ACE-ACC2028BF0DE}"/>
+              </a:ext>
+            </a:extLst>
+          </p:cNvPr>
+          <p:cNvPicPr>
+            <a:picLocks noChangeAspect="1"/>
+          </p:cNvPicPr>
+          <p:nvPr/>
+        </p:nvPicPr>
+        <p:blipFill>
+          <a:blip r:embed="rId3">
+            <a:extLst>
+              <a:ext uri="{28A0092B-C50C-407E-A947-70E740481C1C}">
+                <a14:useLocalDpi xmlns:a14="http://schemas.microsoft.com/office/drawing/2010/main" val="0"/>
+              </a:ext>
+            </a:extLst>
+          </a:blip>
+          <a:stretch>
+            <a:fillRect/>
+          </a:stretch>
+        </p:blipFill>
+        <p:spPr>
+          <a:xfrm>
+            <a:off x="1354501" y="4079954"/>
+            <a:ext cx="8740897" cy="1737511"/>
+          </a:xfrm>
+          <a:prstGeom prst="rect">
+            <a:avLst/>
+          </a:prstGeom>
+        </p:spPr>
+      </p:pic>
+      <p:sp>
+        <p:nvSpPr>
+          <p:cNvPr id="5" name="Geschweifte Klammer rechts 4">
+            <a:extLst>
+              <a:ext uri="{FF2B5EF4-FFF2-40B4-BE49-F238E27FC236}">
+                <a16:creationId xmlns:a16="http://schemas.microsoft.com/office/drawing/2014/main" id="{2BAC3DCD-D25D-08D8-DDED-4B43FF78C1B1}"/>
+              </a:ext>
+            </a:extLst>
+          </p:cNvPr>
+          <p:cNvSpPr/>
+          <p:nvPr/>
+        </p:nvSpPr>
+        <p:spPr>
+          <a:xfrm>
+            <a:off x="8274868" y="3266788"/>
+            <a:ext cx="272358" cy="528196"/>
+          </a:xfrm>
+          <a:prstGeom prst="rightBrace">
+            <a:avLst/>
+          </a:prstGeom>
+          <a:ln>
+            <a:solidFill>
+              <a:srgbClr val="FF0000"/>
+            </a:solidFill>
+          </a:ln>
+        </p:spPr>
+        <p:style>
+          <a:lnRef idx="1">
+            <a:schemeClr val="accent1"/>
+          </a:lnRef>
+          <a:fillRef idx="0">
+            <a:schemeClr val="accent1"/>
+          </a:fillRef>
+          <a:effectRef idx="0">
+            <a:schemeClr val="accent1"/>
+          </a:effectRef>
+          <a:fontRef idx="minor">
+            <a:schemeClr val="tx1"/>
+          </a:fontRef>
+        </p:style>
+        <p:txBody>
+          <a:bodyPr rtlCol="0" anchor="ctr"/>
+          <a:lstStyle/>
+          <a:p>
+            <a:pPr algn="ctr"/>
+            <a:endParaRPr lang="de-DE"/>
+          </a:p>
+        </p:txBody>
+      </p:sp>
+      <p:sp>
+        <p:nvSpPr>
+          <p:cNvPr id="6" name="Textfeld 5">
+            <a:extLst>
+              <a:ext uri="{FF2B5EF4-FFF2-40B4-BE49-F238E27FC236}">
+                <a16:creationId xmlns:a16="http://schemas.microsoft.com/office/drawing/2014/main" id="{422397D4-4586-537A-C7E5-A46670EE0100}"/>
+              </a:ext>
+            </a:extLst>
+          </p:cNvPr>
+          <p:cNvSpPr txBox="1"/>
+          <p:nvPr/>
+        </p:nvSpPr>
+        <p:spPr>
+          <a:xfrm>
+            <a:off x="8526735" y="3329558"/>
+            <a:ext cx="1269115" cy="369332"/>
+          </a:xfrm>
+          <a:prstGeom prst="rect">
+            <a:avLst/>
+          </a:prstGeom>
+          <a:noFill/>
+        </p:spPr>
+        <p:txBody>
+          <a:bodyPr wrap="square" rtlCol="0">
+            <a:spAutoFit/>
+          </a:bodyPr>
+          <a:lstStyle/>
+          <a:p>
+            <a:r>
+              <a:rPr lang="en-US" noProof="0" dirty="0"/>
+              <a:t>Typical use</a:t>
+            </a:r>
+          </a:p>
+        </p:txBody>
+      </p:sp>
+    </p:spTree>
+    <p:extLst>
+      <p:ext uri="{BB962C8B-B14F-4D97-AF65-F5344CB8AC3E}">
+        <p14:creationId xmlns:p14="http://schemas.microsoft.com/office/powerpoint/2010/main" val="2714843014"/>
+      </p:ext>
+    </p:extLst>
+  </p:cSld>
+  <p:clrMapOvr>
+    <a:masterClrMapping/>
+  </p:clrMapOvr>
+</p:sld>
+</file>
+
+<file path=ppt/slides/slide37.xml><?xml version="1.0" encoding="utf-8"?>
+<p:sld xmlns:a="http://schemas.openxmlformats.org/drawingml/2006/main" xmlns:r="http://schemas.openxmlformats.org/officeDocument/2006/relationships" xmlns:p="http://schemas.openxmlformats.org/presentationml/2006/main">
+  <p:cSld>
+    <p:spTree>
+      <p:nvGrpSpPr>
         <p:cNvPr id="1" name=""/>
         <p:cNvGrpSpPr/>
         <p:nvPr/>
@@ -16900,7 +18178,7 @@
           <a:p>
             <a:fld id="{B841CA95-E0BC-48B5-948A-ECC494EB4D84}" type="slidenum">
               <a:rPr lang="en-US" smtClean="0"/>
-              <a:t>36</a:t>
+              <a:t>37</a:t>
             </a:fld>
             <a:endParaRPr lang="en-US"/>
           </a:p>
@@ -17327,199 +18605,6 @@
 </p:sld>
 </file>
 
-<file path=ppt/slides/slide37.xml><?xml version="1.0" encoding="utf-8"?>
-<p:sld xmlns:a="http://schemas.openxmlformats.org/drawingml/2006/main" xmlns:r="http://schemas.openxmlformats.org/officeDocument/2006/relationships" xmlns:p="http://schemas.openxmlformats.org/presentationml/2006/main">
-  <p:cSld>
-    <p:spTree>
-      <p:nvGrpSpPr>
-        <p:cNvPr id="1" name=""/>
-        <p:cNvGrpSpPr/>
-        <p:nvPr/>
-      </p:nvGrpSpPr>
-      <p:grpSpPr>
-        <a:xfrm>
-          <a:off x="0" y="0"/>
-          <a:ext cx="0" cy="0"/>
-          <a:chOff x="0" y="0"/>
-          <a:chExt cx="0" cy="0"/>
-        </a:xfrm>
-      </p:grpSpPr>
-      <p:sp>
-        <p:nvSpPr>
-          <p:cNvPr id="2" name="Title 1"/>
-          <p:cNvSpPr>
-            <a:spLocks noGrp="1"/>
-          </p:cNvSpPr>
-          <p:nvPr>
-            <p:ph type="title"/>
-          </p:nvPr>
-        </p:nvSpPr>
-        <p:spPr/>
-        <p:txBody>
-          <a:bodyPr/>
-          <a:lstStyle/>
-          <a:p>
-            <a:r>
-              <a:rPr lang="en-US" dirty="0"/>
-              <a:t>Missing Values</a:t>
-            </a:r>
-          </a:p>
-        </p:txBody>
-      </p:sp>
-      <p:sp>
-        <p:nvSpPr>
-          <p:cNvPr id="4" name="Slide Number Placeholder 3"/>
-          <p:cNvSpPr>
-            <a:spLocks noGrp="1"/>
-          </p:cNvSpPr>
-          <p:nvPr>
-            <p:ph type="sldNum" sz="quarter" idx="12"/>
-          </p:nvPr>
-        </p:nvSpPr>
-        <p:spPr/>
-        <p:txBody>
-          <a:bodyPr/>
-          <a:lstStyle/>
-          <a:p>
-            <a:fld id="{B841CA95-E0BC-48B5-948A-ECC494EB4D84}" type="slidenum">
-              <a:rPr lang="en-US" smtClean="0"/>
-              <a:t>37</a:t>
-            </a:fld>
-            <a:endParaRPr lang="en-US"/>
-          </a:p>
-        </p:txBody>
-      </p:sp>
-      <p:sp>
-        <p:nvSpPr>
-          <p:cNvPr id="7" name="TextBox 6"/>
-          <p:cNvSpPr txBox="1"/>
-          <p:nvPr/>
-        </p:nvSpPr>
-        <p:spPr>
-          <a:xfrm>
-            <a:off x="991089" y="1770269"/>
-            <a:ext cx="10418164" cy="2677656"/>
-          </a:xfrm>
-          <a:prstGeom prst="rect">
-            <a:avLst/>
-          </a:prstGeom>
-          <a:noFill/>
-        </p:spPr>
-        <p:txBody>
-          <a:bodyPr wrap="square" rtlCol="0">
-            <a:spAutoFit/>
-          </a:bodyPr>
-          <a:lstStyle/>
-          <a:p>
-            <a:pPr marL="342900" indent="-342900">
-              <a:buFont typeface="Arial" panose="020B0604020202020204" pitchFamily="34" charset="0"/>
-              <a:buChar char="•"/>
-            </a:pPr>
-            <a:r>
-              <a:rPr lang="en-US" sz="2400" dirty="0"/>
-              <a:t>When summing the data, missing values will be treated as zero</a:t>
-            </a:r>
-          </a:p>
-          <a:p>
-            <a:pPr marL="342900" indent="-342900">
-              <a:buFont typeface="Arial" panose="020B0604020202020204" pitchFamily="34" charset="0"/>
-              <a:buChar char="•"/>
-            </a:pPr>
-            <a:r>
-              <a:rPr lang="en-US" sz="2400" dirty="0"/>
-              <a:t>If all values are missing, the sum will be equal to </a:t>
-            </a:r>
-            <a:r>
-              <a:rPr lang="en-US" sz="2400" dirty="0" err="1"/>
-              <a:t>NaN</a:t>
-            </a:r>
-            <a:endParaRPr lang="en-US" sz="2400" dirty="0"/>
-          </a:p>
-          <a:p>
-            <a:pPr marL="342900" indent="-342900">
-              <a:buFont typeface="Arial" panose="020B0604020202020204" pitchFamily="34" charset="0"/>
-              <a:buChar char="•"/>
-            </a:pPr>
-            <a:r>
-              <a:rPr lang="en-US" sz="2400" dirty="0" err="1"/>
-              <a:t>cumsum</a:t>
-            </a:r>
-            <a:r>
-              <a:rPr lang="en-US" sz="2400" dirty="0"/>
-              <a:t>() and </a:t>
-            </a:r>
-            <a:r>
-              <a:rPr lang="en-US" sz="2400" dirty="0" err="1"/>
-              <a:t>cumprod</a:t>
-            </a:r>
-            <a:r>
-              <a:rPr lang="en-US" sz="2400" dirty="0"/>
-              <a:t>() methods ignore missing values but preserve them in the resulting arrays</a:t>
-            </a:r>
-          </a:p>
-          <a:p>
-            <a:pPr marL="342900" indent="-342900">
-              <a:buFont typeface="Arial" panose="020B0604020202020204" pitchFamily="34" charset="0"/>
-              <a:buChar char="•"/>
-            </a:pPr>
-            <a:r>
-              <a:rPr lang="en-US" sz="2400" dirty="0"/>
-              <a:t>Missing values in </a:t>
-            </a:r>
-            <a:r>
-              <a:rPr lang="en-US" sz="2400" dirty="0" err="1"/>
-              <a:t>GroupBy</a:t>
-            </a:r>
-            <a:r>
-              <a:rPr lang="en-US" sz="2400" dirty="0"/>
-              <a:t> method are excluded (just like in R)</a:t>
-            </a:r>
-          </a:p>
-          <a:p>
-            <a:pPr marL="342900" indent="-342900">
-              <a:buFont typeface="Arial" panose="020B0604020202020204" pitchFamily="34" charset="0"/>
-              <a:buChar char="•"/>
-            </a:pPr>
-            <a:r>
-              <a:rPr lang="en-US" sz="2400" dirty="0"/>
-              <a:t>Many descriptive statistics methods have </a:t>
-            </a:r>
-            <a:r>
-              <a:rPr lang="en-US" sz="2400" i="1" dirty="0" err="1"/>
-              <a:t>skipna</a:t>
-            </a:r>
-            <a:r>
-              <a:rPr lang="en-US" sz="2400" i="1" dirty="0"/>
-              <a:t> </a:t>
-            </a:r>
-            <a:r>
-              <a:rPr lang="en-US" sz="2400" dirty="0"/>
-              <a:t>option to control if missing data should be excluded . This value is set to </a:t>
-            </a:r>
-            <a:r>
-              <a:rPr lang="en-US" sz="2400" i="1" dirty="0"/>
-              <a:t>True </a:t>
-            </a:r>
-            <a:r>
-              <a:rPr lang="en-US" sz="2400" dirty="0"/>
-              <a:t>by default (unlike R)</a:t>
-            </a:r>
-          </a:p>
-        </p:txBody>
-      </p:sp>
-    </p:spTree>
-    <p:extLst>
-      <p:ext uri="{BB962C8B-B14F-4D97-AF65-F5344CB8AC3E}">
-        <p14:creationId xmlns:p14="http://schemas.microsoft.com/office/powerpoint/2010/main" val="3615251376"/>
-      </p:ext>
-    </p:extLst>
-  </p:cSld>
-  <p:clrMapOvr>
-    <a:masterClrMapping/>
-  </p:clrMapOvr>
-</p:sld>
-</file>
-
 <file path=ppt/slides/slide38.xml><?xml version="1.0" encoding="utf-8"?>
 <p:sld xmlns:a="http://schemas.openxmlformats.org/drawingml/2006/main" xmlns:r="http://schemas.openxmlformats.org/officeDocument/2006/relationships" xmlns:p="http://schemas.openxmlformats.org/presentationml/2006/main">
   <p:cSld>
@@ -17554,7 +18639,7 @@
           <a:p>
             <a:r>
               <a:rPr lang="en-US" dirty="0"/>
-              <a:t>Aggregation Functions in Pandas</a:t>
+              <a:t>Missing Values</a:t>
             </a:r>
           </a:p>
         </p:txBody>
@@ -17591,7 +18676,7 @@
         <p:spPr>
           <a:xfrm>
             <a:off x="991089" y="1770269"/>
-            <a:ext cx="10418164" cy="4154984"/>
+            <a:ext cx="10418164" cy="2677656"/>
           </a:xfrm>
           <a:prstGeom prst="rect">
             <a:avLst/>
@@ -17604,85 +18689,98 @@
           </a:bodyPr>
           <a:lstStyle/>
           <a:p>
-            <a:r>
-              <a:rPr lang="en-US" sz="2400" dirty="0"/>
-              <a:t>Aggregation - computing a summary statistic about each group, i.e.</a:t>
-            </a:r>
-          </a:p>
-          <a:p>
-            <a:pPr marL="800100" lvl="1" indent="-342900">
+            <a:pPr marL="342900" indent="-342900">
               <a:buFont typeface="Arial" panose="020B0604020202020204" pitchFamily="34" charset="0"/>
               <a:buChar char="•"/>
             </a:pPr>
             <a:r>
               <a:rPr lang="en-US" sz="2400" dirty="0"/>
-              <a:t>compute group sums or means</a:t>
-            </a:r>
-          </a:p>
-          <a:p>
-            <a:pPr marL="800100" lvl="1" indent="-342900">
+              <a:t>When summing the data, missing values will be treated as zero</a:t>
+            </a:r>
+          </a:p>
+          <a:p>
+            <a:pPr marL="342900" indent="-342900">
               <a:buFont typeface="Arial" panose="020B0604020202020204" pitchFamily="34" charset="0"/>
               <a:buChar char="•"/>
             </a:pPr>
             <a:r>
               <a:rPr lang="en-US" sz="2400" dirty="0"/>
-              <a:t>compute group sizes/counts</a:t>
-            </a:r>
-          </a:p>
-          <a:p>
-            <a:pPr lvl="1"/>
+              <a:t>If all values are missing, the sum will be equal to </a:t>
+            </a:r>
+            <a:r>
+              <a:rPr lang="en-US" sz="2400" dirty="0" err="1"/>
+              <a:t>NaN</a:t>
+            </a:r>
             <a:endParaRPr lang="en-US" sz="2400" dirty="0"/>
           </a:p>
           <a:p>
+            <a:pPr marL="342900" indent="-342900">
+              <a:buFont typeface="Arial" panose="020B0604020202020204" pitchFamily="34" charset="0"/>
+              <a:buChar char="•"/>
+            </a:pPr>
+            <a:r>
+              <a:rPr lang="en-US" sz="2400" dirty="0" err="1"/>
+              <a:t>cumsum</a:t>
+            </a:r>
             <a:r>
               <a:rPr lang="en-US" sz="2400" dirty="0"/>
-              <a:t>Common aggregation functions:</a:t>
-            </a:r>
-          </a:p>
-          <a:p>
-            <a:endParaRPr lang="en-US" sz="2400" dirty="0"/>
-          </a:p>
-          <a:p>
-            <a:pPr lvl="1"/>
+              <a:t>() and </a:t>
+            </a:r>
+            <a:r>
+              <a:rPr lang="en-US" sz="2400" dirty="0" err="1"/>
+              <a:t>cumprod</a:t>
+            </a:r>
             <a:r>
               <a:rPr lang="en-US" sz="2400" dirty="0"/>
-              <a:t>min, max</a:t>
-            </a:r>
-          </a:p>
-          <a:p>
-            <a:pPr lvl="1"/>
+              <a:t>() methods ignore missing values but preserve them in the resulting arrays</a:t>
+            </a:r>
+          </a:p>
+          <a:p>
+            <a:pPr marL="342900" indent="-342900">
+              <a:buFont typeface="Arial" panose="020B0604020202020204" pitchFamily="34" charset="0"/>
+              <a:buChar char="•"/>
+            </a:pPr>
             <a:r>
               <a:rPr lang="en-US" sz="2400" dirty="0"/>
-              <a:t>count, sum, prod</a:t>
-            </a:r>
-          </a:p>
-          <a:p>
-            <a:pPr lvl="1"/>
+              <a:t>Missing values in </a:t>
+            </a:r>
+            <a:r>
+              <a:rPr lang="en-US" sz="2400" dirty="0" err="1"/>
+              <a:t>GroupBy</a:t>
+            </a:r>
             <a:r>
               <a:rPr lang="en-US" sz="2400" dirty="0"/>
-              <a:t>mean, median, mode, mad</a:t>
-            </a:r>
-          </a:p>
-          <a:p>
-            <a:pPr lvl="1"/>
-            <a:r>
-              <a:rPr lang="en-US" sz="2400" dirty="0" err="1"/>
-              <a:t>std</a:t>
-            </a:r>
+              <a:t> method are excluded (just like in R)</a:t>
+            </a:r>
+          </a:p>
+          <a:p>
+            <a:pPr marL="342900" indent="-342900">
+              <a:buFont typeface="Arial" panose="020B0604020202020204" pitchFamily="34" charset="0"/>
+              <a:buChar char="•"/>
+            </a:pPr>
             <a:r>
               <a:rPr lang="en-US" sz="2400" dirty="0"/>
-              <a:t>, </a:t>
-            </a:r>
-            <a:r>
-              <a:rPr lang="en-US" sz="2400" dirty="0" err="1"/>
-              <a:t>var</a:t>
-            </a:r>
-            <a:endParaRPr lang="en-US" sz="2400" dirty="0"/>
-          </a:p>
-          <a:p>
+              <a:t>Many descriptive statistics methods have </a:t>
+            </a:r>
+            <a:r>
+              <a:rPr lang="en-US" sz="2400" i="1" dirty="0" err="1"/>
+              <a:t>skipna</a:t>
+            </a:r>
+            <a:r>
+              <a:rPr lang="en-US" sz="2400" i="1" dirty="0"/>
+              <a:t> </a:t>
+            </a:r>
             <a:r>
               <a:rPr lang="en-US" sz="2400" dirty="0"/>
-              <a:t> </a:t>
+              <a:t>option to control if missing data should be excluded . This value is set to </a:t>
+            </a:r>
+            <a:r>
+              <a:rPr lang="en-US" sz="2400" i="1" dirty="0"/>
+              <a:t>True </a:t>
+            </a:r>
+            <a:r>
+              <a:rPr lang="en-US" sz="2400" dirty="0"/>
+              <a:t>by default (unlike R)</a:t>
             </a:r>
           </a:p>
         </p:txBody>
@@ -17690,7 +18788,7 @@
     </p:spTree>
     <p:extLst>
       <p:ext uri="{BB962C8B-B14F-4D97-AF65-F5344CB8AC3E}">
-        <p14:creationId xmlns:p14="http://schemas.microsoft.com/office/powerpoint/2010/main" val="2097279667"/>
+        <p14:creationId xmlns:p14="http://schemas.microsoft.com/office/powerpoint/2010/main" val="3615251376"/>
       </p:ext>
     </p:extLst>
   </p:cSld>
@@ -17757,6 +18855,439 @@
             <a:fld id="{B841CA95-E0BC-48B5-948A-ECC494EB4D84}" type="slidenum">
               <a:rPr lang="en-US" smtClean="0"/>
               <a:t>39</a:t>
+            </a:fld>
+            <a:endParaRPr lang="en-US"/>
+          </a:p>
+        </p:txBody>
+      </p:sp>
+      <p:sp>
+        <p:nvSpPr>
+          <p:cNvPr id="7" name="TextBox 6"/>
+          <p:cNvSpPr txBox="1"/>
+          <p:nvPr/>
+        </p:nvSpPr>
+        <p:spPr>
+          <a:xfrm>
+            <a:off x="991089" y="1770269"/>
+            <a:ext cx="10418164" cy="4154984"/>
+          </a:xfrm>
+          <a:prstGeom prst="rect">
+            <a:avLst/>
+          </a:prstGeom>
+          <a:noFill/>
+        </p:spPr>
+        <p:txBody>
+          <a:bodyPr wrap="square" rtlCol="0">
+            <a:spAutoFit/>
+          </a:bodyPr>
+          <a:lstStyle/>
+          <a:p>
+            <a:r>
+              <a:rPr lang="en-US" sz="2400" dirty="0"/>
+              <a:t>Aggregation - computing a summary statistic about each group, i.e.</a:t>
+            </a:r>
+          </a:p>
+          <a:p>
+            <a:pPr marL="800100" lvl="1" indent="-342900">
+              <a:buFont typeface="Arial" panose="020B0604020202020204" pitchFamily="34" charset="0"/>
+              <a:buChar char="•"/>
+            </a:pPr>
+            <a:r>
+              <a:rPr lang="en-US" sz="2400" dirty="0"/>
+              <a:t>compute group sums or means</a:t>
+            </a:r>
+          </a:p>
+          <a:p>
+            <a:pPr marL="800100" lvl="1" indent="-342900">
+              <a:buFont typeface="Arial" panose="020B0604020202020204" pitchFamily="34" charset="0"/>
+              <a:buChar char="•"/>
+            </a:pPr>
+            <a:r>
+              <a:rPr lang="en-US" sz="2400" dirty="0"/>
+              <a:t>compute group sizes/counts</a:t>
+            </a:r>
+          </a:p>
+          <a:p>
+            <a:pPr lvl="1"/>
+            <a:endParaRPr lang="en-US" sz="2400" dirty="0"/>
+          </a:p>
+          <a:p>
+            <a:r>
+              <a:rPr lang="en-US" sz="2400" dirty="0"/>
+              <a:t>Common aggregation functions:</a:t>
+            </a:r>
+          </a:p>
+          <a:p>
+            <a:endParaRPr lang="en-US" sz="2400" dirty="0"/>
+          </a:p>
+          <a:p>
+            <a:pPr lvl="1"/>
+            <a:r>
+              <a:rPr lang="en-US" sz="2400" dirty="0"/>
+              <a:t>min, max</a:t>
+            </a:r>
+          </a:p>
+          <a:p>
+            <a:pPr lvl="1"/>
+            <a:r>
+              <a:rPr lang="en-US" sz="2400" dirty="0"/>
+              <a:t>count, sum, prod</a:t>
+            </a:r>
+          </a:p>
+          <a:p>
+            <a:pPr lvl="1"/>
+            <a:r>
+              <a:rPr lang="en-US" sz="2400" dirty="0"/>
+              <a:t>mean, median, mode, mad</a:t>
+            </a:r>
+          </a:p>
+          <a:p>
+            <a:pPr lvl="1"/>
+            <a:r>
+              <a:rPr lang="en-US" sz="2400" dirty="0" err="1"/>
+              <a:t>std</a:t>
+            </a:r>
+            <a:r>
+              <a:rPr lang="en-US" sz="2400" dirty="0"/>
+              <a:t>, </a:t>
+            </a:r>
+            <a:r>
+              <a:rPr lang="en-US" sz="2400" dirty="0" err="1"/>
+              <a:t>var</a:t>
+            </a:r>
+            <a:endParaRPr lang="en-US" sz="2400" dirty="0"/>
+          </a:p>
+          <a:p>
+            <a:r>
+              <a:rPr lang="en-US" sz="2400" dirty="0"/>
+              <a:t> </a:t>
+            </a:r>
+          </a:p>
+        </p:txBody>
+      </p:sp>
+    </p:spTree>
+    <p:extLst>
+      <p:ext uri="{BB962C8B-B14F-4D97-AF65-F5344CB8AC3E}">
+        <p14:creationId xmlns:p14="http://schemas.microsoft.com/office/powerpoint/2010/main" val="2097279667"/>
+      </p:ext>
+    </p:extLst>
+  </p:cSld>
+  <p:clrMapOvr>
+    <a:masterClrMapping/>
+  </p:clrMapOvr>
+</p:sld>
+</file>
+
+<file path=ppt/slides/slide4.xml><?xml version="1.0" encoding="utf-8"?>
+<p:sld xmlns:a="http://schemas.openxmlformats.org/drawingml/2006/main" xmlns:r="http://schemas.openxmlformats.org/officeDocument/2006/relationships" xmlns:p="http://schemas.openxmlformats.org/presentationml/2006/main">
+  <p:cSld>
+    <p:spTree>
+      <p:nvGrpSpPr>
+        <p:cNvPr id="1" name=""/>
+        <p:cNvGrpSpPr/>
+        <p:nvPr/>
+      </p:nvGrpSpPr>
+      <p:grpSpPr>
+        <a:xfrm>
+          <a:off x="0" y="0"/>
+          <a:ext cx="0" cy="0"/>
+          <a:chOff x="0" y="0"/>
+          <a:chExt cx="0" cy="0"/>
+        </a:xfrm>
+      </p:grpSpPr>
+      <p:sp>
+        <p:nvSpPr>
+          <p:cNvPr id="2" name="Title 1"/>
+          <p:cNvSpPr>
+            <a:spLocks noGrp="1"/>
+          </p:cNvSpPr>
+          <p:nvPr>
+            <p:ph type="title"/>
+          </p:nvPr>
+        </p:nvSpPr>
+        <p:spPr/>
+        <p:txBody>
+          <a:bodyPr/>
+          <a:lstStyle/>
+          <a:p>
+            <a:r>
+              <a:rPr lang="en-US" dirty="0"/>
+              <a:t>Python Libraries for Data Science/ML</a:t>
+            </a:r>
+          </a:p>
+        </p:txBody>
+      </p:sp>
+      <p:sp>
+        <p:nvSpPr>
+          <p:cNvPr id="3" name="Content Placeholder 2"/>
+          <p:cNvSpPr>
+            <a:spLocks noGrp="1"/>
+          </p:cNvSpPr>
+          <p:nvPr>
+            <p:ph idx="1"/>
+          </p:nvPr>
+        </p:nvSpPr>
+        <p:spPr/>
+        <p:txBody>
+          <a:bodyPr>
+            <a:normAutofit lnSpcReduction="10000"/>
+          </a:bodyPr>
+          <a:lstStyle/>
+          <a:p>
+            <a:pPr marL="0" indent="0">
+              <a:buNone/>
+            </a:pPr>
+            <a:r>
+              <a:rPr lang="en-US" dirty="0"/>
+              <a:t>Many popular Python toolboxes/libraries:</a:t>
+            </a:r>
+          </a:p>
+          <a:p>
+            <a:pPr lvl="1"/>
+            <a:r>
+              <a:rPr lang="en-US" dirty="0" err="1"/>
+              <a:t>NumPy</a:t>
+            </a:r>
+            <a:endParaRPr lang="en-US" dirty="0"/>
+          </a:p>
+          <a:p>
+            <a:pPr lvl="1"/>
+            <a:r>
+              <a:rPr lang="en-US" dirty="0" err="1">
+                <a:highlight>
+                  <a:srgbClr val="FFFF00"/>
+                </a:highlight>
+              </a:rPr>
+              <a:t>SciPy</a:t>
+            </a:r>
+            <a:endParaRPr lang="en-US" dirty="0">
+              <a:highlight>
+                <a:srgbClr val="FFFF00"/>
+              </a:highlight>
+            </a:endParaRPr>
+          </a:p>
+          <a:p>
+            <a:pPr lvl="1"/>
+            <a:r>
+              <a:rPr lang="en-US" dirty="0"/>
+              <a:t>Pandas</a:t>
+            </a:r>
+          </a:p>
+          <a:p>
+            <a:pPr lvl="1"/>
+            <a:r>
+              <a:rPr lang="en-US" dirty="0" err="1">
+                <a:highlight>
+                  <a:srgbClr val="FFFF00"/>
+                </a:highlight>
+              </a:rPr>
+              <a:t>SciKit</a:t>
+            </a:r>
+            <a:r>
+              <a:rPr lang="en-US" dirty="0">
+                <a:highlight>
+                  <a:srgbClr val="FFFF00"/>
+                </a:highlight>
+              </a:rPr>
+              <a:t>-Learn</a:t>
+            </a:r>
+          </a:p>
+          <a:p>
+            <a:pPr marL="457200" lvl="1" indent="0">
+              <a:buNone/>
+            </a:pPr>
+            <a:endParaRPr lang="en-US" dirty="0"/>
+          </a:p>
+          <a:p>
+            <a:pPr marL="0" indent="0">
+              <a:buNone/>
+            </a:pPr>
+            <a:r>
+              <a:rPr lang="en-US" dirty="0"/>
+              <a:t>Visualization libraries</a:t>
+            </a:r>
+          </a:p>
+          <a:p>
+            <a:pPr lvl="1"/>
+            <a:r>
+              <a:rPr lang="en-US" dirty="0" err="1">
+                <a:highlight>
+                  <a:srgbClr val="FFFF00"/>
+                </a:highlight>
+              </a:rPr>
+              <a:t>matplotlib</a:t>
+            </a:r>
+            <a:endParaRPr lang="en-US" dirty="0">
+              <a:highlight>
+                <a:srgbClr val="FFFF00"/>
+              </a:highlight>
+            </a:endParaRPr>
+          </a:p>
+          <a:p>
+            <a:pPr lvl="1"/>
+            <a:r>
+              <a:rPr lang="en-US" dirty="0" err="1">
+                <a:highlight>
+                  <a:srgbClr val="FFFF00"/>
+                </a:highlight>
+              </a:rPr>
+              <a:t>Seaborn</a:t>
+            </a:r>
+            <a:endParaRPr lang="en-US" dirty="0">
+              <a:highlight>
+                <a:srgbClr val="FFFF00"/>
+              </a:highlight>
+            </a:endParaRPr>
+          </a:p>
+          <a:p>
+            <a:pPr lvl="1"/>
+            <a:endParaRPr lang="en-US" dirty="0"/>
+          </a:p>
+          <a:p>
+            <a:pPr marL="457200" lvl="1" indent="0">
+              <a:buNone/>
+            </a:pPr>
+            <a:r>
+              <a:rPr lang="en-US" dirty="0"/>
+              <a:t>                                                      and many more …</a:t>
+            </a:r>
+          </a:p>
+        </p:txBody>
+      </p:sp>
+      <p:sp>
+        <p:nvSpPr>
+          <p:cNvPr id="4" name="Slide Number Placeholder 3"/>
+          <p:cNvSpPr>
+            <a:spLocks noGrp="1"/>
+          </p:cNvSpPr>
+          <p:nvPr>
+            <p:ph type="sldNum" sz="quarter" idx="12"/>
+          </p:nvPr>
+        </p:nvSpPr>
+        <p:spPr/>
+        <p:txBody>
+          <a:bodyPr/>
+          <a:lstStyle/>
+          <a:p>
+            <a:fld id="{B841CA95-E0BC-48B5-948A-ECC494EB4D84}" type="slidenum">
+              <a:rPr lang="en-US" smtClean="0"/>
+              <a:t>4</a:t>
+            </a:fld>
+            <a:endParaRPr lang="en-US"/>
+          </a:p>
+        </p:txBody>
+      </p:sp>
+      <p:sp>
+        <p:nvSpPr>
+          <p:cNvPr id="7" name="TextBox 6"/>
+          <p:cNvSpPr txBox="1"/>
+          <p:nvPr/>
+        </p:nvSpPr>
+        <p:spPr>
+          <a:xfrm>
+            <a:off x="4538472" y="2846832"/>
+            <a:ext cx="2237232" cy="1200329"/>
+          </a:xfrm>
+          <a:prstGeom prst="rect">
+            <a:avLst/>
+          </a:prstGeom>
+          <a:noFill/>
+        </p:spPr>
+        <p:txBody>
+          <a:bodyPr wrap="square" rtlCol="0">
+            <a:spAutoFit/>
+          </a:bodyPr>
+          <a:lstStyle/>
+          <a:p>
+            <a:r>
+              <a:rPr lang="en-US" i="1" dirty="0"/>
+              <a:t>All these libraries </a:t>
+            </a:r>
+            <a:r>
+              <a:rPr lang="en-US" i="1" dirty="0">
+                <a:highlight>
+                  <a:srgbClr val="00FFFF"/>
+                </a:highlight>
+              </a:rPr>
+              <a:t>might</a:t>
+            </a:r>
+            <a:r>
+              <a:rPr lang="en-US" i="1" dirty="0"/>
+              <a:t> need to be installed on your notebook!</a:t>
+            </a:r>
+          </a:p>
+        </p:txBody>
+      </p:sp>
+    </p:spTree>
+    <p:extLst>
+      <p:ext uri="{BB962C8B-B14F-4D97-AF65-F5344CB8AC3E}">
+        <p14:creationId xmlns:p14="http://schemas.microsoft.com/office/powerpoint/2010/main" val="3973478858"/>
+      </p:ext>
+    </p:extLst>
+  </p:cSld>
+  <p:clrMapOvr>
+    <a:masterClrMapping/>
+  </p:clrMapOvr>
+</p:sld>
+</file>
+
+<file path=ppt/slides/slide40.xml><?xml version="1.0" encoding="utf-8"?>
+<p:sld xmlns:a="http://schemas.openxmlformats.org/drawingml/2006/main" xmlns:r="http://schemas.openxmlformats.org/officeDocument/2006/relationships" xmlns:p="http://schemas.openxmlformats.org/presentationml/2006/main">
+  <p:cSld>
+    <p:spTree>
+      <p:nvGrpSpPr>
+        <p:cNvPr id="1" name=""/>
+        <p:cNvGrpSpPr/>
+        <p:nvPr/>
+      </p:nvGrpSpPr>
+      <p:grpSpPr>
+        <a:xfrm>
+          <a:off x="0" y="0"/>
+          <a:ext cx="0" cy="0"/>
+          <a:chOff x="0" y="0"/>
+          <a:chExt cx="0" cy="0"/>
+        </a:xfrm>
+      </p:grpSpPr>
+      <p:sp>
+        <p:nvSpPr>
+          <p:cNvPr id="2" name="Title 1"/>
+          <p:cNvSpPr>
+            <a:spLocks noGrp="1"/>
+          </p:cNvSpPr>
+          <p:nvPr>
+            <p:ph type="title"/>
+          </p:nvPr>
+        </p:nvSpPr>
+        <p:spPr/>
+        <p:txBody>
+          <a:bodyPr/>
+          <a:lstStyle/>
+          <a:p>
+            <a:r>
+              <a:rPr lang="en-US" dirty="0"/>
+              <a:t>Aggregation Functions in Pandas</a:t>
+            </a:r>
+          </a:p>
+        </p:txBody>
+      </p:sp>
+      <p:sp>
+        <p:nvSpPr>
+          <p:cNvPr id="4" name="Slide Number Placeholder 3"/>
+          <p:cNvSpPr>
+            <a:spLocks noGrp="1"/>
+          </p:cNvSpPr>
+          <p:nvPr>
+            <p:ph type="sldNum" sz="quarter" idx="12"/>
+          </p:nvPr>
+        </p:nvSpPr>
+        <p:spPr/>
+        <p:txBody>
+          <a:bodyPr/>
+          <a:lstStyle/>
+          <a:p>
+            <a:fld id="{B841CA95-E0BC-48B5-948A-ECC494EB4D84}" type="slidenum">
+              <a:rPr lang="en-US" smtClean="0"/>
+              <a:t>40</a:t>
             </a:fld>
             <a:endParaRPr lang="en-US"/>
           </a:p>
@@ -18150,7 +19681,7 @@
 </p:sld>
 </file>
 
-<file path=ppt/slides/slide4.xml><?xml version="1.0" encoding="utf-8"?>
+<file path=ppt/slides/slide41.xml><?xml version="1.0" encoding="utf-8"?>
 <p:sld xmlns:a="http://schemas.openxmlformats.org/drawingml/2006/main" xmlns:r="http://schemas.openxmlformats.org/officeDocument/2006/relationships" xmlns:p="http://schemas.openxmlformats.org/presentationml/2006/main">
   <p:cSld>
     <p:spTree>
@@ -18184,144 +19715,7 @@
           <a:p>
             <a:r>
               <a:rPr lang="en-US" dirty="0"/>
-              <a:t>Python Libraries for Data Science/ML</a:t>
-            </a:r>
-          </a:p>
-        </p:txBody>
-      </p:sp>
-      <p:sp>
-        <p:nvSpPr>
-          <p:cNvPr id="3" name="Content Placeholder 2"/>
-          <p:cNvSpPr>
-            <a:spLocks noGrp="1"/>
-          </p:cNvSpPr>
-          <p:nvPr>
-            <p:ph idx="1"/>
-          </p:nvPr>
-        </p:nvSpPr>
-        <p:spPr/>
-        <p:txBody>
-          <a:bodyPr>
-            <a:normAutofit lnSpcReduction="10000"/>
-          </a:bodyPr>
-          <a:lstStyle/>
-          <a:p>
-            <a:pPr marL="0" indent="0">
-              <a:buNone/>
-            </a:pPr>
-            <a:r>
-              <a:rPr lang="en-US" dirty="0"/>
-              <a:t>Many popular Python toolboxes/libraries:</a:t>
-            </a:r>
-          </a:p>
-          <a:p>
-            <a:pPr lvl="1"/>
-            <a:r>
-              <a:rPr lang="en-US" dirty="0" err="1"/>
-              <a:t>NumPy</a:t>
-            </a:r>
-            <a:endParaRPr lang="en-US" dirty="0"/>
-          </a:p>
-          <a:p>
-            <a:pPr lvl="1"/>
-            <a:r>
-              <a:rPr lang="en-US" dirty="0" err="1">
-                <a:highlight>
-                  <a:srgbClr val="FFFF00"/>
-                </a:highlight>
-              </a:rPr>
-              <a:t>SciPy</a:t>
-            </a:r>
-            <a:endParaRPr lang="en-US" dirty="0">
-              <a:highlight>
-                <a:srgbClr val="FFFF00"/>
-              </a:highlight>
-            </a:endParaRPr>
-          </a:p>
-          <a:p>
-            <a:pPr lvl="1"/>
-            <a:r>
-              <a:rPr lang="en-US" dirty="0"/>
-              <a:t>Pandas</a:t>
-            </a:r>
-          </a:p>
-          <a:p>
-            <a:pPr lvl="1"/>
-            <a:r>
-              <a:rPr lang="en-US" dirty="0" err="1">
-                <a:highlight>
-                  <a:srgbClr val="FFFF00"/>
-                </a:highlight>
-              </a:rPr>
-              <a:t>SciKit</a:t>
-            </a:r>
-            <a:r>
-              <a:rPr lang="en-US" dirty="0">
-                <a:highlight>
-                  <a:srgbClr val="FFFF00"/>
-                </a:highlight>
-              </a:rPr>
-              <a:t>-Learn</a:t>
-            </a:r>
-          </a:p>
-          <a:p>
-            <a:pPr marL="457200" lvl="1" indent="0">
-              <a:buNone/>
-            </a:pPr>
-            <a:endParaRPr lang="en-US" dirty="0"/>
-          </a:p>
-          <a:p>
-            <a:pPr marL="0" indent="0">
-              <a:buNone/>
-            </a:pPr>
-            <a:r>
-              <a:rPr lang="en-US" dirty="0"/>
-              <a:t>Visualization libraries</a:t>
-            </a:r>
-          </a:p>
-          <a:p>
-            <a:pPr lvl="1"/>
-            <a:r>
-              <a:rPr lang="en-US" dirty="0" err="1">
-                <a:highlight>
-                  <a:srgbClr val="FFFF00"/>
-                </a:highlight>
-              </a:rPr>
-              <a:t>matplotlib</a:t>
-            </a:r>
-            <a:endParaRPr lang="en-US" dirty="0">
-              <a:highlight>
-                <a:srgbClr val="FFFF00"/>
-              </a:highlight>
-            </a:endParaRPr>
-          </a:p>
-          <a:p>
-            <a:pPr lvl="1"/>
-            <a:r>
-              <a:rPr lang="en-US" dirty="0" err="1">
-                <a:highlight>
-                  <a:srgbClr val="FFFF00"/>
-                </a:highlight>
-              </a:rPr>
-              <a:t>Seaborn</a:t>
-            </a:r>
-            <a:endParaRPr lang="en-US" dirty="0">
-              <a:highlight>
-                <a:srgbClr val="FFFF00"/>
-              </a:highlight>
-            </a:endParaRPr>
-          </a:p>
-          <a:p>
-            <a:pPr lvl="1"/>
-            <a:endParaRPr lang="en-US" dirty="0"/>
-          </a:p>
-          <a:p>
-            <a:pPr marL="457200" lvl="1" indent="0">
-              <a:buNone/>
-            </a:pPr>
-            <a:r>
-              <a:rPr lang="en-US" dirty="0"/>
-              <a:t>                                                      and many more …</a:t>
+              <a:t>Basic Descriptive Statistics</a:t>
             </a:r>
           </a:p>
         </p:txBody>
@@ -18343,123 +19737,7 @@
           <a:p>
             <a:fld id="{B841CA95-E0BC-48B5-948A-ECC494EB4D84}" type="slidenum">
               <a:rPr lang="en-US" smtClean="0"/>
-              <a:t>4</a:t>
-            </a:fld>
-            <a:endParaRPr lang="en-US"/>
-          </a:p>
-        </p:txBody>
-      </p:sp>
-      <p:sp>
-        <p:nvSpPr>
-          <p:cNvPr id="7" name="TextBox 6"/>
-          <p:cNvSpPr txBox="1"/>
-          <p:nvPr/>
-        </p:nvSpPr>
-        <p:spPr>
-          <a:xfrm>
-            <a:off x="4538472" y="2846832"/>
-            <a:ext cx="2237232" cy="1200329"/>
-          </a:xfrm>
-          <a:prstGeom prst="rect">
-            <a:avLst/>
-          </a:prstGeom>
-          <a:noFill/>
-        </p:spPr>
-        <p:txBody>
-          <a:bodyPr wrap="square" rtlCol="0">
-            <a:spAutoFit/>
-          </a:bodyPr>
-          <a:lstStyle/>
-          <a:p>
-            <a:r>
-              <a:rPr lang="en-US" i="1" dirty="0"/>
-              <a:t>All these libraries </a:t>
-            </a:r>
-            <a:r>
-              <a:rPr lang="en-US" i="1" dirty="0">
-                <a:highlight>
-                  <a:srgbClr val="00FFFF"/>
-                </a:highlight>
-              </a:rPr>
-              <a:t>might</a:t>
-            </a:r>
-            <a:r>
-              <a:rPr lang="en-US" i="1" dirty="0"/>
-              <a:t> need to be installed on your notebook!</a:t>
-            </a:r>
-          </a:p>
-        </p:txBody>
-      </p:sp>
-    </p:spTree>
-    <p:extLst>
-      <p:ext uri="{BB962C8B-B14F-4D97-AF65-F5344CB8AC3E}">
-        <p14:creationId xmlns:p14="http://schemas.microsoft.com/office/powerpoint/2010/main" val="3973478858"/>
-      </p:ext>
-    </p:extLst>
-  </p:cSld>
-  <p:clrMapOvr>
-    <a:masterClrMapping/>
-  </p:clrMapOvr>
-</p:sld>
-</file>
-
-<file path=ppt/slides/slide40.xml><?xml version="1.0" encoding="utf-8"?>
-<p:sld xmlns:a="http://schemas.openxmlformats.org/drawingml/2006/main" xmlns:r="http://schemas.openxmlformats.org/officeDocument/2006/relationships" xmlns:p="http://schemas.openxmlformats.org/presentationml/2006/main">
-  <p:cSld>
-    <p:spTree>
-      <p:nvGrpSpPr>
-        <p:cNvPr id="1" name=""/>
-        <p:cNvGrpSpPr/>
-        <p:nvPr/>
-      </p:nvGrpSpPr>
-      <p:grpSpPr>
-        <a:xfrm>
-          <a:off x="0" y="0"/>
-          <a:ext cx="0" cy="0"/>
-          <a:chOff x="0" y="0"/>
-          <a:chExt cx="0" cy="0"/>
-        </a:xfrm>
-      </p:grpSpPr>
-      <p:sp>
-        <p:nvSpPr>
-          <p:cNvPr id="2" name="Title 1"/>
-          <p:cNvSpPr>
-            <a:spLocks noGrp="1"/>
-          </p:cNvSpPr>
-          <p:nvPr>
-            <p:ph type="title"/>
-          </p:nvPr>
-        </p:nvSpPr>
-        <p:spPr/>
-        <p:txBody>
-          <a:bodyPr/>
-          <a:lstStyle/>
-          <a:p>
-            <a:r>
-              <a:rPr lang="en-US" dirty="0"/>
-              <a:t>Basic Descriptive Statistics</a:t>
-            </a:r>
-          </a:p>
-        </p:txBody>
-      </p:sp>
-      <p:sp>
-        <p:nvSpPr>
-          <p:cNvPr id="4" name="Slide Number Placeholder 3"/>
-          <p:cNvSpPr>
-            <a:spLocks noGrp="1"/>
-          </p:cNvSpPr>
-          <p:nvPr>
-            <p:ph type="sldNum" sz="quarter" idx="12"/>
-          </p:nvPr>
-        </p:nvSpPr>
-        <p:spPr/>
-        <p:txBody>
-          <a:bodyPr/>
-          <a:lstStyle/>
-          <a:p>
-            <a:fld id="{B841CA95-E0BC-48B5-948A-ECC494EB4D84}" type="slidenum">
-              <a:rPr lang="en-US" smtClean="0"/>
-              <a:t>40</a:t>
+              <a:t>41</a:t>
             </a:fld>
             <a:endParaRPr lang="en-US"/>
           </a:p>
@@ -18848,7 +20126,7 @@
 </p:sld>
 </file>
 
-<file path=ppt/slides/slide41.xml><?xml version="1.0" encoding="utf-8"?>
+<file path=ppt/slides/slide42.xml><?xml version="1.0" encoding="utf-8"?>
 <p:sld xmlns:a="http://schemas.openxmlformats.org/drawingml/2006/main" xmlns:r="http://schemas.openxmlformats.org/officeDocument/2006/relationships" xmlns:p="http://schemas.openxmlformats.org/presentationml/2006/main">
   <p:cSld>
     <p:spTree>
@@ -18908,7 +20186,7 @@
           <a:p>
             <a:fld id="{B841CA95-E0BC-48B5-948A-ECC494EB4D84}" type="slidenum">
               <a:rPr lang="en-US" smtClean="0"/>
-              <a:t>41</a:t>
+              <a:t>42</a:t>
             </a:fld>
             <a:endParaRPr lang="en-US"/>
           </a:p>
@@ -19104,6 +20382,47 @@
           </a:p>
         </p:txBody>
       </p:sp>
+      <p:cxnSp>
+        <p:nvCxnSpPr>
+          <p:cNvPr id="8" name="Gerader Verbinder 7">
+            <a:extLst>
+              <a:ext uri="{FF2B5EF4-FFF2-40B4-BE49-F238E27FC236}">
+                <a16:creationId xmlns:a16="http://schemas.microsoft.com/office/drawing/2014/main" id="{83B55431-5556-0BAA-DA08-A1164C535120}"/>
+              </a:ext>
+            </a:extLst>
+          </p:cNvPr>
+          <p:cNvCxnSpPr/>
+          <p:nvPr/>
+        </p:nvCxnSpPr>
+        <p:spPr>
+          <a:xfrm flipH="1">
+            <a:off x="552261" y="365125"/>
+            <a:ext cx="10936587" cy="5809338"/>
+          </a:xfrm>
+          <a:prstGeom prst="line">
+            <a:avLst/>
+          </a:prstGeom>
+          <a:ln>
+            <a:solidFill>
+              <a:srgbClr val="FF0000"/>
+            </a:solidFill>
+          </a:ln>
+        </p:spPr>
+        <p:style>
+          <a:lnRef idx="1">
+            <a:schemeClr val="accent1"/>
+          </a:lnRef>
+          <a:fillRef idx="0">
+            <a:schemeClr val="accent1"/>
+          </a:fillRef>
+          <a:effectRef idx="0">
+            <a:schemeClr val="accent1"/>
+          </a:effectRef>
+          <a:fontRef idx="minor">
+            <a:schemeClr val="tx1"/>
+          </a:fontRef>
+        </p:style>
+      </p:cxnSp>
     </p:spTree>
     <p:extLst>
       <p:ext uri="{BB962C8B-B14F-4D97-AF65-F5344CB8AC3E}">
@@ -19117,7 +20436,7 @@
 </p:sld>
 </file>
 
-<file path=ppt/slides/slide42.xml><?xml version="1.0" encoding="utf-8"?>
+<file path=ppt/slides/slide43.xml><?xml version="1.0" encoding="utf-8"?>
 <p:sld xmlns:a="http://schemas.openxmlformats.org/drawingml/2006/main" xmlns:r="http://schemas.openxmlformats.org/officeDocument/2006/relationships" xmlns:p="http://schemas.openxmlformats.org/presentationml/2006/main">
   <p:cSld>
     <p:spTree>
@@ -19173,7 +20492,7 @@
           <a:p>
             <a:fld id="{B841CA95-E0BC-48B5-948A-ECC494EB4D84}" type="slidenum">
               <a:rPr lang="en-US" smtClean="0"/>
-              <a:t>42</a:t>
+              <a:t>43</a:t>
             </a:fld>
             <a:endParaRPr lang="en-US"/>
           </a:p>
@@ -19653,7 +20972,7 @@
 </p:sld>
 </file>
 
-<file path=ppt/slides/slide43.xml><?xml version="1.0" encoding="utf-8"?>
+<file path=ppt/slides/slide44.xml><?xml version="1.0" encoding="utf-8"?>
 <p:sld xmlns:a="http://schemas.openxmlformats.org/drawingml/2006/main" xmlns:r="http://schemas.openxmlformats.org/officeDocument/2006/relationships" xmlns:p="http://schemas.openxmlformats.org/presentationml/2006/main">
   <p:cSld>
     <p:spTree>
@@ -19709,7 +21028,7 @@
           <a:p>
             <a:fld id="{B841CA95-E0BC-48B5-948A-ECC494EB4D84}" type="slidenum">
               <a:rPr lang="en-US" smtClean="0"/>
-              <a:t>43</a:t>
+              <a:t>44</a:t>
             </a:fld>
             <a:endParaRPr lang="en-US"/>
           </a:p>

</xml_diff>